<commit_message>
assets: simplify poster right card and enlarge task categories
</commit_message>
<xml_diff>
--- a/assets/sjtu-bench-poster-16x9.pptx
+++ b/assets/sjtu-bench-poster-16x9.pptx
@@ -3104,8 +3104,8 @@
         </p:nvSpPr>
         <p:spPr>
           <a:xfrm>
-            <a:off x="10241280" y="-1280160"/>
-            <a:ext cx="3840480" cy="3840480"/>
+            <a:off x="10332720" y="-1371600"/>
+            <a:ext cx="3931920" cy="3931920"/>
           </a:xfrm>
           <a:prstGeom prst="ellipse">
             <a:avLst/>
@@ -3147,8 +3147,8 @@
         </p:nvSpPr>
         <p:spPr>
           <a:xfrm>
-            <a:off x="10972800" y="4206240"/>
-            <a:ext cx="2377440" cy="2377440"/>
+            <a:off x="11155680" y="4114800"/>
+            <a:ext cx="2468880" cy="2468880"/>
           </a:xfrm>
           <a:prstGeom prst="ellipse">
             <a:avLst/>
@@ -3190,8 +3190,8 @@
         </p:nvSpPr>
         <p:spPr>
           <a:xfrm>
-            <a:off x="9509760" y="5120640"/>
-            <a:ext cx="1280160" cy="1280160"/>
+            <a:off x="9601200" y="5212080"/>
+            <a:ext cx="1188720" cy="1188720"/>
           </a:xfrm>
           <a:prstGeom prst="ellipse">
             <a:avLst/>
@@ -3276,12 +3276,12 @@
         </p:nvSpPr>
         <p:spPr>
           <a:xfrm>
-            <a:off x="640080" y="502920"/>
-            <a:ext cx="3017520" cy="384048"/>
+            <a:off x="640080" y="457200"/>
+            <a:ext cx="2926080" cy="365760"/>
           </a:xfrm>
           <a:prstGeom prst="roundRect">
             <a:avLst>
-              <a:gd name="adj" fmla="val 8000"/>
+              <a:gd name="adj" fmla="val 10000"/>
             </a:avLst>
           </a:prstGeom>
           <a:solidFill>
@@ -3321,8 +3321,8 @@
         </p:nvSpPr>
         <p:spPr>
           <a:xfrm>
-            <a:off x="749808" y="566928"/>
-            <a:ext cx="2834640" cy="274320"/>
+            <a:off x="758952" y="512064"/>
+            <a:ext cx="2743200" cy="274320"/>
           </a:xfrm>
           <a:prstGeom prst="rect">
             <a:avLst/>
@@ -3341,7 +3341,7 @@
               </a:lnSpc>
             </a:pPr>
             <a:r>
-              <a:rPr sz="1100" b="1">
+              <a:rPr sz="1050" b="1">
                 <a:solidFill>
                   <a:srgbClr val="22D3EE"/>
                 </a:solidFill>
@@ -3361,8 +3361,8 @@
         </p:nvSpPr>
         <p:spPr>
           <a:xfrm>
-            <a:off x="640080" y="987552"/>
-            <a:ext cx="8595360" cy="822960"/>
+            <a:off x="640080" y="932688"/>
+            <a:ext cx="7315200" cy="822960"/>
           </a:xfrm>
           <a:prstGeom prst="rect">
             <a:avLst/>
@@ -3406,8 +3406,8 @@
         </p:nvSpPr>
         <p:spPr>
           <a:xfrm>
-            <a:off x="658368" y="1883664"/>
-            <a:ext cx="7680960" cy="566928"/>
+            <a:off x="658368" y="1810512"/>
+            <a:ext cx="7498079" cy="640080"/>
           </a:xfrm>
           <a:prstGeom prst="rect">
             <a:avLst/>
@@ -3415,25 +3415,30 @@
           <a:noFill/>
         </p:spPr>
         <p:txBody>
-          <a:bodyPr wrap="square" anchor="t" lIns="0" rIns="0" tIns="0" bIns="0">
+          <a:bodyPr wrap="none" lIns="0" rIns="0" tIns="0" bIns="0">
             <a:spAutoFit/>
           </a:bodyPr>
           <a:lstStyle/>
           <a:p>
-            <a:pPr algn="l">
-              <a:lnSpc>
-                <a:spcPct val="100000"/>
-              </a:lnSpc>
-            </a:pPr>
-            <a:r>
-              <a:rPr sz="2800" b="1">
+            <a:r>
+              <a:rPr sz="3000" b="1">
+                <a:solidFill>
+                  <a:srgbClr val="22D3EE"/>
+                </a:solidFill>
+                <a:latin typeface="Microsoft YaHei"/>
+                <a:ea typeface="Microsoft YaHei"/>
+              </a:rPr>
+              <a:t>AI </a:t>
+            </a:r>
+            <a:r>
+              <a:rPr sz="3000" b="1">
                 <a:solidFill>
                   <a:srgbClr val="F8FAFC"/>
                 </a:solidFill>
                 <a:latin typeface="Microsoft YaHei"/>
                 <a:ea typeface="Microsoft YaHei"/>
               </a:rPr>
-              <a:t>15 个任务，测测你的校园 AI</a:t>
+              <a:t>帮你掌握校园的一切</a:t>
             </a:r>
           </a:p>
         </p:txBody>
@@ -3446,8 +3451,8 @@
         </p:nvSpPr>
         <p:spPr>
           <a:xfrm>
-            <a:off x="658368" y="2505456"/>
-            <a:ext cx="7589520" cy="457200"/>
+            <a:off x="676656" y="2487168"/>
+            <a:ext cx="7315200" cy="365760"/>
           </a:xfrm>
           <a:prstGeom prst="rect">
             <a:avLst/>
@@ -3466,14 +3471,14 @@
               </a:lnSpc>
             </a:pPr>
             <a:r>
-              <a:rPr sz="1500" b="0">
+              <a:rPr sz="1400" b="0">
                 <a:solidFill>
                   <a:srgbClr val="94A3B8"/>
                 </a:solidFill>
                 <a:latin typeface="Microsoft YaHei"/>
                 <a:ea typeface="Microsoft YaHei"/>
               </a:rPr>
-              <a:t>登一次 jAccount，看 AI 能不能真的帮你办事</a:t>
+              <a:t>15 个真实校园任务 · L1–L4</a:t>
             </a:r>
           </a:p>
         </p:txBody>
@@ -3486,16 +3491,16 @@
         </p:nvSpPr>
         <p:spPr>
           <a:xfrm>
-            <a:off x="658368" y="3218688"/>
-            <a:ext cx="566928" cy="329184"/>
+            <a:off x="640080" y="3072384"/>
+            <a:ext cx="6629400" cy="713232"/>
           </a:xfrm>
           <a:prstGeom prst="roundRect">
             <a:avLst>
-              <a:gd name="adj" fmla="val 8000"/>
+              <a:gd name="adj" fmla="val 10000"/>
             </a:avLst>
           </a:prstGeom>
           <a:solidFill>
-            <a:srgbClr val="A3E635"/>
+            <a:srgbClr val="121C2E"/>
           </a:solidFill>
           <a:ln>
             <a:noFill/>
@@ -3525,102 +3530,22 @@
       </p:sp>
       <p:sp>
         <p:nvSpPr>
-          <p:cNvPr id="12" name="TextBox 11"/>
-          <p:cNvSpPr txBox="1"/>
-          <p:nvPr/>
-        </p:nvSpPr>
-        <p:spPr>
-          <a:xfrm>
-            <a:off x="658368" y="3241548"/>
-            <a:ext cx="566928" cy="274320"/>
-          </a:xfrm>
-          <a:prstGeom prst="rect">
-            <a:avLst/>
-          </a:prstGeom>
-          <a:noFill/>
-        </p:spPr>
-        <p:txBody>
-          <a:bodyPr wrap="square" anchor="t" lIns="0" rIns="0" tIns="0" bIns="0">
-            <a:spAutoFit/>
-          </a:bodyPr>
-          <a:lstStyle/>
-          <a:p>
-            <a:pPr algn="ctr">
-              <a:lnSpc>
-                <a:spcPct val="100000"/>
-              </a:lnSpc>
-            </a:pPr>
-            <a:r>
-              <a:rPr sz="1200" b="1">
-                <a:solidFill>
-                  <a:srgbClr val="0B1220"/>
-                </a:solidFill>
-                <a:latin typeface="Microsoft YaHei"/>
-                <a:ea typeface="Microsoft YaHei"/>
-              </a:rPr>
-              <a:t>L1</a:t>
-            </a:r>
-          </a:p>
-        </p:txBody>
-      </p:sp>
-      <p:sp>
-        <p:nvSpPr>
-          <p:cNvPr id="13" name="TextBox 12"/>
-          <p:cNvSpPr txBox="1"/>
-          <p:nvPr/>
-        </p:nvSpPr>
-        <p:spPr>
-          <a:xfrm>
-            <a:off x="1353312" y="3209544"/>
-            <a:ext cx="6126480" cy="384048"/>
-          </a:xfrm>
-          <a:prstGeom prst="rect">
-            <a:avLst/>
-          </a:prstGeom>
-          <a:noFill/>
-        </p:spPr>
-        <p:txBody>
-          <a:bodyPr wrap="square" anchor="t" lIns="0" rIns="0" tIns="0" bIns="0">
-            <a:spAutoFit/>
-          </a:bodyPr>
-          <a:lstStyle/>
-          <a:p>
-            <a:pPr algn="l">
-              <a:lnSpc>
-                <a:spcPct val="100000"/>
-              </a:lnSpc>
-            </a:pPr>
-            <a:r>
-              <a:rPr sz="1300" b="0">
-                <a:solidFill>
-                  <a:srgbClr val="F8FAFC"/>
-                </a:solidFill>
-                <a:latin typeface="Microsoft YaHei"/>
-                <a:ea typeface="Microsoft YaHei"/>
-              </a:rPr>
-              <a:t>查课表 / 通知 / 水源 / 交我办</a:t>
-            </a:r>
-          </a:p>
-        </p:txBody>
-      </p:sp>
-      <p:sp>
-        <p:nvSpPr>
-          <p:cNvPr id="14" name="Rounded Rectangle 13"/>
+          <p:cNvPr id="12" name="Rounded Rectangle 11"/>
           <p:cNvSpPr/>
           <p:nvPr/>
         </p:nvSpPr>
         <p:spPr>
           <a:xfrm>
-            <a:off x="658368" y="3721608"/>
-            <a:ext cx="566928" cy="329184"/>
+            <a:off x="640080" y="3072384"/>
+            <a:ext cx="822960" cy="713232"/>
           </a:xfrm>
           <a:prstGeom prst="roundRect">
             <a:avLst>
-              <a:gd name="adj" fmla="val 8000"/>
+              <a:gd name="adj" fmla="val 10000"/>
             </a:avLst>
           </a:prstGeom>
           <a:solidFill>
-            <a:srgbClr val="22D3EE"/>
+            <a:srgbClr val="A3E635"/>
           </a:solidFill>
           <a:ln>
             <a:noFill/>
@@ -3650,14 +3575,14 @@
       </p:sp>
       <p:sp>
         <p:nvSpPr>
-          <p:cNvPr id="15" name="TextBox 14"/>
+          <p:cNvPr id="13" name="TextBox 12"/>
           <p:cNvSpPr txBox="1"/>
           <p:nvPr/>
         </p:nvSpPr>
         <p:spPr>
           <a:xfrm>
-            <a:off x="658368" y="3744468"/>
-            <a:ext cx="566928" cy="274320"/>
+            <a:off x="640080" y="3246120"/>
+            <a:ext cx="822960" cy="365760"/>
           </a:xfrm>
           <a:prstGeom prst="rect">
             <a:avLst/>
@@ -3676,28 +3601,28 @@
               </a:lnSpc>
             </a:pPr>
             <a:r>
-              <a:rPr sz="1200" b="1">
+              <a:rPr sz="1700" b="1">
                 <a:solidFill>
                   <a:srgbClr val="0B1220"/>
                 </a:solidFill>
                 <a:latin typeface="Microsoft YaHei"/>
                 <a:ea typeface="Microsoft YaHei"/>
               </a:rPr>
-              <a:t>L2</a:t>
-            </a:r>
-          </a:p>
-        </p:txBody>
-      </p:sp>
-      <p:sp>
-        <p:nvSpPr>
-          <p:cNvPr id="16" name="TextBox 15"/>
+              <a:t>L1</a:t>
+            </a:r>
+          </a:p>
+        </p:txBody>
+      </p:sp>
+      <p:sp>
+        <p:nvSpPr>
+          <p:cNvPr id="14" name="TextBox 13"/>
           <p:cNvSpPr txBox="1"/>
           <p:nvPr/>
         </p:nvSpPr>
         <p:spPr>
           <a:xfrm>
-            <a:off x="1353312" y="3712464"/>
-            <a:ext cx="6126480" cy="384048"/>
+            <a:off x="1691640" y="3200400"/>
+            <a:ext cx="5394960" cy="457200"/>
           </a:xfrm>
           <a:prstGeom prst="rect">
             <a:avLst/>
@@ -3716,36 +3641,36 @@
               </a:lnSpc>
             </a:pPr>
             <a:r>
-              <a:rPr sz="1300" b="0">
+              <a:rPr sz="1600" b="1">
                 <a:solidFill>
                   <a:srgbClr val="F8FAFC"/>
                 </a:solidFill>
                 <a:latin typeface="Microsoft YaHei"/>
                 <a:ea typeface="Microsoft YaHei"/>
               </a:rPr>
-              <a:t>跨源汇总：DDL、公众号、邮箱、活动</a:t>
-            </a:r>
-          </a:p>
-        </p:txBody>
-      </p:sp>
-      <p:sp>
-        <p:nvSpPr>
-          <p:cNvPr id="17" name="Rounded Rectangle 16"/>
+              <a:t>查课表 / 通知 / 水源 / 交我办</a:t>
+            </a:r>
+          </a:p>
+        </p:txBody>
+      </p:sp>
+      <p:sp>
+        <p:nvSpPr>
+          <p:cNvPr id="15" name="Rounded Rectangle 14"/>
           <p:cNvSpPr/>
           <p:nvPr/>
         </p:nvSpPr>
         <p:spPr>
           <a:xfrm>
-            <a:off x="658368" y="4224528"/>
-            <a:ext cx="566928" cy="329184"/>
+            <a:off x="640080" y="3931920"/>
+            <a:ext cx="6629400" cy="713232"/>
           </a:xfrm>
           <a:prstGeom prst="roundRect">
             <a:avLst>
-              <a:gd name="adj" fmla="val 8000"/>
+              <a:gd name="adj" fmla="val 10000"/>
             </a:avLst>
           </a:prstGeom>
           <a:solidFill>
-            <a:srgbClr val="FB923C"/>
+            <a:srgbClr val="121C2E"/>
           </a:solidFill>
           <a:ln>
             <a:noFill/>
@@ -3775,102 +3700,22 @@
       </p:sp>
       <p:sp>
         <p:nvSpPr>
-          <p:cNvPr id="18" name="TextBox 17"/>
-          <p:cNvSpPr txBox="1"/>
-          <p:nvPr/>
-        </p:nvSpPr>
-        <p:spPr>
-          <a:xfrm>
-            <a:off x="658368" y="4247388"/>
-            <a:ext cx="566928" cy="274320"/>
-          </a:xfrm>
-          <a:prstGeom prst="rect">
-            <a:avLst/>
-          </a:prstGeom>
-          <a:noFill/>
-        </p:spPr>
-        <p:txBody>
-          <a:bodyPr wrap="square" anchor="t" lIns="0" rIns="0" tIns="0" bIns="0">
-            <a:spAutoFit/>
-          </a:bodyPr>
-          <a:lstStyle/>
-          <a:p>
-            <a:pPr algn="ctr">
-              <a:lnSpc>
-                <a:spcPct val="100000"/>
-              </a:lnSpc>
-            </a:pPr>
-            <a:r>
-              <a:rPr sz="1200" b="1">
-                <a:solidFill>
-                  <a:srgbClr val="0B1220"/>
-                </a:solidFill>
-                <a:latin typeface="Microsoft YaHei"/>
-                <a:ea typeface="Microsoft YaHei"/>
-              </a:rPr>
-              <a:t>L3</a:t>
-            </a:r>
-          </a:p>
-        </p:txBody>
-      </p:sp>
-      <p:sp>
-        <p:nvSpPr>
-          <p:cNvPr id="19" name="TextBox 18"/>
-          <p:cNvSpPr txBox="1"/>
-          <p:nvPr/>
-        </p:nvSpPr>
-        <p:spPr>
-          <a:xfrm>
-            <a:off x="1353312" y="4215384"/>
-            <a:ext cx="6126480" cy="384048"/>
-          </a:xfrm>
-          <a:prstGeom prst="rect">
-            <a:avLst/>
-          </a:prstGeom>
-          <a:noFill/>
-        </p:spPr>
-        <p:txBody>
-          <a:bodyPr wrap="square" anchor="t" lIns="0" rIns="0" tIns="0" bIns="0">
-            <a:spAutoFit/>
-          </a:bodyPr>
-          <a:lstStyle/>
-          <a:p>
-            <a:pPr algn="l">
-              <a:lnSpc>
-                <a:spcPct val="100000"/>
-              </a:lnSpc>
-            </a:pPr>
-            <a:r>
-              <a:rPr sz="1300" b="0">
-                <a:solidFill>
-                  <a:srgbClr val="F8FAFC"/>
-                </a:solidFill>
-                <a:latin typeface="Microsoft YaHei"/>
-                <a:ea typeface="Microsoft YaHei"/>
-              </a:rPr>
-              <a:t>多步操作：政务流程 / 云盘 / 报销（只预填）</a:t>
-            </a:r>
-          </a:p>
-        </p:txBody>
-      </p:sp>
-      <p:sp>
-        <p:nvSpPr>
-          <p:cNvPr id="20" name="Rounded Rectangle 19"/>
+          <p:cNvPr id="16" name="Rounded Rectangle 15"/>
           <p:cNvSpPr/>
           <p:nvPr/>
         </p:nvSpPr>
         <p:spPr>
           <a:xfrm>
-            <a:off x="658368" y="4727448"/>
-            <a:ext cx="566928" cy="329184"/>
+            <a:off x="640080" y="3931920"/>
+            <a:ext cx="822960" cy="713232"/>
           </a:xfrm>
           <a:prstGeom prst="roundRect">
             <a:avLst>
-              <a:gd name="adj" fmla="val 8000"/>
+              <a:gd name="adj" fmla="val 10000"/>
             </a:avLst>
           </a:prstGeom>
           <a:solidFill>
-            <a:srgbClr val="C4B5FD"/>
+            <a:srgbClr val="22D3EE"/>
           </a:solidFill>
           <a:ln>
             <a:noFill/>
@@ -3900,14 +3745,14 @@
       </p:sp>
       <p:sp>
         <p:nvSpPr>
-          <p:cNvPr id="21" name="TextBox 20"/>
+          <p:cNvPr id="17" name="TextBox 16"/>
           <p:cNvSpPr txBox="1"/>
           <p:nvPr/>
         </p:nvSpPr>
         <p:spPr>
           <a:xfrm>
-            <a:off x="658368" y="4750308"/>
-            <a:ext cx="566928" cy="274320"/>
+            <a:off x="640080" y="4105656"/>
+            <a:ext cx="822960" cy="365760"/>
           </a:xfrm>
           <a:prstGeom prst="rect">
             <a:avLst/>
@@ -3926,28 +3771,28 @@
               </a:lnSpc>
             </a:pPr>
             <a:r>
-              <a:rPr sz="1200" b="1">
+              <a:rPr sz="1700" b="1">
                 <a:solidFill>
                   <a:srgbClr val="0B1220"/>
                 </a:solidFill>
                 <a:latin typeface="Microsoft YaHei"/>
                 <a:ea typeface="Microsoft YaHei"/>
               </a:rPr>
-              <a:t>L4</a:t>
-            </a:r>
-          </a:p>
-        </p:txBody>
-      </p:sp>
-      <p:sp>
-        <p:nvSpPr>
-          <p:cNvPr id="22" name="TextBox 21"/>
+              <a:t>L2</a:t>
+            </a:r>
+          </a:p>
+        </p:txBody>
+      </p:sp>
+      <p:sp>
+        <p:nvSpPr>
+          <p:cNvPr id="18" name="TextBox 17"/>
           <p:cNvSpPr txBox="1"/>
           <p:nvPr/>
         </p:nvSpPr>
         <p:spPr>
           <a:xfrm>
-            <a:off x="1353312" y="4718304"/>
-            <a:ext cx="6126480" cy="384048"/>
+            <a:off x="1691640" y="4059935"/>
+            <a:ext cx="5394960" cy="457200"/>
           </a:xfrm>
           <a:prstGeom prst="rect">
             <a:avLst/>
@@ -3966,32 +3811,32 @@
               </a:lnSpc>
             </a:pPr>
             <a:r>
-              <a:rPr sz="1300" b="0">
+              <a:rPr sz="1600" b="1">
                 <a:solidFill>
                   <a:srgbClr val="F8FAFC"/>
                 </a:solidFill>
                 <a:latin typeface="Microsoft YaHei"/>
                 <a:ea typeface="Microsoft YaHei"/>
               </a:rPr>
-              <a:t>每日简报 / 工作流设计 / 你的 Agent 方案</a:t>
-            </a:r>
-          </a:p>
-        </p:txBody>
-      </p:sp>
-      <p:sp>
-        <p:nvSpPr>
-          <p:cNvPr id="23" name="Rounded Rectangle 22"/>
+              <a:t>DDL / 公众号 / 邮箱 / 活动</a:t>
+            </a:r>
+          </a:p>
+        </p:txBody>
+      </p:sp>
+      <p:sp>
+        <p:nvSpPr>
+          <p:cNvPr id="19" name="Rounded Rectangle 18"/>
           <p:cNvSpPr/>
           <p:nvPr/>
         </p:nvSpPr>
         <p:spPr>
           <a:xfrm>
-            <a:off x="7726679" y="1417320"/>
-            <a:ext cx="3886200" cy="4434840"/>
+            <a:off x="640080" y="4791456"/>
+            <a:ext cx="6629400" cy="713232"/>
           </a:xfrm>
           <a:prstGeom prst="roundRect">
             <a:avLst>
-              <a:gd name="adj" fmla="val 8000"/>
+              <a:gd name="adj" fmla="val 10000"/>
             </a:avLst>
           </a:prstGeom>
           <a:solidFill>
@@ -4025,22 +3870,22 @@
       </p:sp>
       <p:sp>
         <p:nvSpPr>
-          <p:cNvPr id="24" name="Rounded Rectangle 23"/>
+          <p:cNvPr id="20" name="Rounded Rectangle 19"/>
           <p:cNvSpPr/>
           <p:nvPr/>
         </p:nvSpPr>
         <p:spPr>
           <a:xfrm>
-            <a:off x="8001000" y="1691640"/>
-            <a:ext cx="3337560" cy="475488"/>
+            <a:off x="640080" y="4791456"/>
+            <a:ext cx="822960" cy="713232"/>
           </a:xfrm>
           <a:prstGeom prst="roundRect">
             <a:avLst>
-              <a:gd name="adj" fmla="val 8000"/>
+              <a:gd name="adj" fmla="val 10000"/>
             </a:avLst>
           </a:prstGeom>
           <a:solidFill>
-            <a:srgbClr val="22D3EE"/>
+            <a:srgbClr val="FB923C"/>
           </a:solidFill>
           <a:ln>
             <a:noFill/>
@@ -4070,14 +3915,14 @@
       </p:sp>
       <p:sp>
         <p:nvSpPr>
-          <p:cNvPr id="25" name="TextBox 24"/>
+          <p:cNvPr id="21" name="TextBox 20"/>
           <p:cNvSpPr txBox="1"/>
           <p:nvPr/>
         </p:nvSpPr>
         <p:spPr>
           <a:xfrm>
-            <a:off x="8001000" y="1773936"/>
-            <a:ext cx="3337560" cy="292608"/>
+            <a:off x="640080" y="4965192"/>
+            <a:ext cx="822960" cy="365760"/>
           </a:xfrm>
           <a:prstGeom prst="rect">
             <a:avLst/>
@@ -4096,28 +3941,28 @@
               </a:lnSpc>
             </a:pPr>
             <a:r>
-              <a:rPr sz="1200" b="1">
+              <a:rPr sz="1700" b="1">
                 <a:solidFill>
                   <a:srgbClr val="0B1220"/>
                 </a:solidFill>
                 <a:latin typeface="Microsoft YaHei"/>
                 <a:ea typeface="Microsoft YaHei"/>
               </a:rPr>
-              <a:t>对 agent 说这句话</a:t>
-            </a:r>
-          </a:p>
-        </p:txBody>
-      </p:sp>
-      <p:sp>
-        <p:nvSpPr>
-          <p:cNvPr id="26" name="TextBox 25"/>
+              <a:t>L3</a:t>
+            </a:r>
+          </a:p>
+        </p:txBody>
+      </p:sp>
+      <p:sp>
+        <p:nvSpPr>
+          <p:cNvPr id="22" name="TextBox 21"/>
           <p:cNvSpPr txBox="1"/>
           <p:nvPr/>
         </p:nvSpPr>
         <p:spPr>
           <a:xfrm>
-            <a:off x="7955279" y="2395728"/>
-            <a:ext cx="3429000" cy="914400"/>
+            <a:off x="1691640" y="4919472"/>
+            <a:ext cx="5394960" cy="457200"/>
           </a:xfrm>
           <a:prstGeom prst="rect">
             <a:avLst/>
@@ -4130,241 +3975,42 @@
           </a:bodyPr>
           <a:lstStyle/>
           <a:p>
-            <a:pPr algn="ctr">
+            <a:pPr algn="l">
               <a:lnSpc>
-                <a:spcPct val="110000"/>
+                <a:spcPct val="100000"/>
               </a:lnSpc>
             </a:pPr>
             <a:r>
-              <a:rPr sz="2000" b="1">
+              <a:rPr sz="1600" b="1">
                 <a:solidFill>
                   <a:srgbClr val="F8FAFC"/>
                 </a:solidFill>
                 <a:latin typeface="Microsoft YaHei"/>
                 <a:ea typeface="Microsoft YaHei"/>
               </a:rPr>
-              <a:t>“我要试一试
-sjtubench”</a:t>
-            </a:r>
-          </a:p>
-        </p:txBody>
-      </p:sp>
-      <p:sp>
-        <p:nvSpPr>
-          <p:cNvPr id="27" name="TextBox 26"/>
-          <p:cNvSpPr txBox="1"/>
-          <p:nvPr/>
-        </p:nvSpPr>
-        <p:spPr>
-          <a:xfrm>
-            <a:off x="7973568" y="3401568"/>
-            <a:ext cx="3383280" cy="365760"/>
-          </a:xfrm>
-          <a:prstGeom prst="rect">
-            <a:avLst/>
-          </a:prstGeom>
-          <a:noFill/>
-        </p:spPr>
-        <p:txBody>
-          <a:bodyPr wrap="square" anchor="t" lIns="0" rIns="0" tIns="0" bIns="0">
-            <a:spAutoFit/>
-          </a:bodyPr>
-          <a:lstStyle/>
-          <a:p>
-            <a:pPr algn="ctr">
-              <a:lnSpc>
-                <a:spcPct val="100000"/>
-              </a:lnSpc>
-            </a:pPr>
-            <a:r>
-              <a:rPr sz="1200" b="0">
-                <a:solidFill>
-                  <a:srgbClr val="94A3B8"/>
-                </a:solidFill>
-                <a:latin typeface="Microsoft YaHei"/>
-                <a:ea typeface="Microsoft YaHei"/>
-              </a:rPr>
-              <a:t>↓ 自动跑完 15 个任务</a:t>
-            </a:r>
-          </a:p>
-        </p:txBody>
-      </p:sp>
-      <p:sp>
-        <p:nvSpPr>
-          <p:cNvPr id="28" name="TextBox 27"/>
-          <p:cNvSpPr txBox="1"/>
-          <p:nvPr/>
-        </p:nvSpPr>
-        <p:spPr>
-          <a:xfrm>
-            <a:off x="8092440" y="3886200"/>
-            <a:ext cx="3200400" cy="292608"/>
-          </a:xfrm>
-          <a:prstGeom prst="rect">
-            <a:avLst/>
-          </a:prstGeom>
-          <a:noFill/>
-        </p:spPr>
-        <p:txBody>
-          <a:bodyPr wrap="square" anchor="t" lIns="0" rIns="0" tIns="0" bIns="0">
-            <a:spAutoFit/>
-          </a:bodyPr>
-          <a:lstStyle/>
-          <a:p>
-            <a:pPr algn="l">
-              <a:lnSpc>
-                <a:spcPct val="100000"/>
-              </a:lnSpc>
-            </a:pPr>
-            <a:r>
-              <a:rPr sz="1150" b="0">
-                <a:solidFill>
-                  <a:srgbClr val="94A3B8"/>
-                </a:solidFill>
-                <a:latin typeface="Microsoft YaHei"/>
-                <a:ea typeface="Microsoft YaHei"/>
-              </a:rPr>
-              <a:t>1. 装好 sjtu-mcp + DSH</a:t>
-            </a:r>
-          </a:p>
-        </p:txBody>
-      </p:sp>
-      <p:sp>
-        <p:nvSpPr>
-          <p:cNvPr id="29" name="TextBox 28"/>
-          <p:cNvSpPr txBox="1"/>
-          <p:nvPr/>
-        </p:nvSpPr>
-        <p:spPr>
-          <a:xfrm>
-            <a:off x="8092440" y="4233672"/>
-            <a:ext cx="3200400" cy="292608"/>
-          </a:xfrm>
-          <a:prstGeom prst="rect">
-            <a:avLst/>
-          </a:prstGeom>
-          <a:noFill/>
-        </p:spPr>
-        <p:txBody>
-          <a:bodyPr wrap="square" anchor="t" lIns="0" rIns="0" tIns="0" bIns="0">
-            <a:spAutoFit/>
-          </a:bodyPr>
-          <a:lstStyle/>
-          <a:p>
-            <a:pPr algn="l">
-              <a:lnSpc>
-                <a:spcPct val="100000"/>
-              </a:lnSpc>
-            </a:pPr>
-            <a:r>
-              <a:rPr sz="1150" b="0">
-                <a:solidFill>
-                  <a:srgbClr val="94A3B8"/>
-                </a:solidFill>
-                <a:latin typeface="Microsoft YaHei"/>
-                <a:ea typeface="Microsoft YaHei"/>
-              </a:rPr>
-              <a:t>2. 登录一次 jAccount</a:t>
-            </a:r>
-          </a:p>
-        </p:txBody>
-      </p:sp>
-      <p:sp>
-        <p:nvSpPr>
-          <p:cNvPr id="30" name="TextBox 29"/>
-          <p:cNvSpPr txBox="1"/>
-          <p:nvPr/>
-        </p:nvSpPr>
-        <p:spPr>
-          <a:xfrm>
-            <a:off x="8092440" y="4581144"/>
-            <a:ext cx="3200400" cy="292608"/>
-          </a:xfrm>
-          <a:prstGeom prst="rect">
-            <a:avLst/>
-          </a:prstGeom>
-          <a:noFill/>
-        </p:spPr>
-        <p:txBody>
-          <a:bodyPr wrap="square" anchor="t" lIns="0" rIns="0" tIns="0" bIns="0">
-            <a:spAutoFit/>
-          </a:bodyPr>
-          <a:lstStyle/>
-          <a:p>
-            <a:pPr algn="l">
-              <a:lnSpc>
-                <a:spcPct val="100000"/>
-              </a:lnSpc>
-            </a:pPr>
-            <a:r>
-              <a:rPr sz="1150" b="0">
-                <a:solidFill>
-                  <a:srgbClr val="94A3B8"/>
-                </a:solidFill>
-                <a:latin typeface="Microsoft YaHei"/>
-                <a:ea typeface="Microsoft YaHei"/>
-              </a:rPr>
-              <a:t>3. 跑完可选上榜</a:t>
-            </a:r>
-          </a:p>
-        </p:txBody>
-      </p:sp>
-      <p:sp>
-        <p:nvSpPr>
-          <p:cNvPr id="31" name="TextBox 30"/>
-          <p:cNvSpPr txBox="1"/>
-          <p:nvPr/>
-        </p:nvSpPr>
-        <p:spPr>
-          <a:xfrm>
-            <a:off x="7973568" y="5257800"/>
-            <a:ext cx="3383280" cy="365760"/>
-          </a:xfrm>
-          <a:prstGeom prst="rect">
-            <a:avLst/>
-          </a:prstGeom>
-          <a:noFill/>
-        </p:spPr>
-        <p:txBody>
-          <a:bodyPr wrap="square" anchor="t" lIns="0" rIns="0" tIns="0" bIns="0">
-            <a:spAutoFit/>
-          </a:bodyPr>
-          <a:lstStyle/>
-          <a:p>
-            <a:pPr algn="ctr">
-              <a:lnSpc>
-                <a:spcPct val="100000"/>
-              </a:lnSpc>
-            </a:pPr>
-            <a:r>
-              <a:rPr sz="1050" b="0">
-                <a:solidFill>
-                  <a:srgbClr val="22D3EE"/>
-                </a:solidFill>
-                <a:latin typeface="Microsoft YaHei"/>
-                <a:ea typeface="Microsoft YaHei"/>
-              </a:rPr>
-              <a:t>LLM 评分 · 匿名排行 · 隐私不出本机</a:t>
-            </a:r>
-          </a:p>
-        </p:txBody>
-      </p:sp>
-      <p:sp>
-        <p:nvSpPr>
-          <p:cNvPr id="32" name="Rectangle 31"/>
+              <a:t>政务流程 / 云盘 / 报销（只预填）</a:t>
+            </a:r>
+          </a:p>
+        </p:txBody>
+      </p:sp>
+      <p:sp>
+        <p:nvSpPr>
+          <p:cNvPr id="23" name="Rounded Rectangle 22"/>
           <p:cNvSpPr/>
           <p:nvPr/>
         </p:nvSpPr>
         <p:spPr>
           <a:xfrm>
-            <a:off x="0" y="6144768"/>
-            <a:ext cx="12191695" cy="713232"/>
-          </a:xfrm>
-          <a:prstGeom prst="rect">
-            <a:avLst/>
+            <a:off x="640080" y="5650992"/>
+            <a:ext cx="6629400" cy="713232"/>
+          </a:xfrm>
+          <a:prstGeom prst="roundRect">
+            <a:avLst>
+              <a:gd name="adj" fmla="val 10000"/>
+            </a:avLst>
           </a:prstGeom>
           <a:solidFill>
-            <a:srgbClr val="0F1828"/>
+            <a:srgbClr val="121C2E"/>
           </a:solidFill>
           <a:ln>
             <a:noFill/>
@@ -4394,14 +4040,99 @@
       </p:sp>
       <p:sp>
         <p:nvSpPr>
-          <p:cNvPr id="33" name="TextBox 32"/>
+          <p:cNvPr id="24" name="Rounded Rectangle 23"/>
+          <p:cNvSpPr/>
+          <p:nvPr/>
+        </p:nvSpPr>
+        <p:spPr>
+          <a:xfrm>
+            <a:off x="640080" y="5650992"/>
+            <a:ext cx="822960" cy="713232"/>
+          </a:xfrm>
+          <a:prstGeom prst="roundRect">
+            <a:avLst>
+              <a:gd name="adj" fmla="val 10000"/>
+            </a:avLst>
+          </a:prstGeom>
+          <a:solidFill>
+            <a:srgbClr val="C4B5FD"/>
+          </a:solidFill>
+          <a:ln>
+            <a:noFill/>
+          </a:ln>
+        </p:spPr>
+        <p:style>
+          <a:lnRef idx="1">
+            <a:schemeClr val="accent1"/>
+          </a:lnRef>
+          <a:fillRef idx="3">
+            <a:schemeClr val="accent1"/>
+          </a:fillRef>
+          <a:effectRef idx="2">
+            <a:schemeClr val="accent1"/>
+          </a:effectRef>
+          <a:fontRef idx="minor">
+            <a:schemeClr val="lt1"/>
+          </a:fontRef>
+        </p:style>
+        <p:txBody>
+          <a:bodyPr rtlCol="0" anchor="ctr"/>
+          <a:lstStyle/>
+          <a:p>
+            <a:pPr algn="ctr"/>
+          </a:p>
+        </p:txBody>
+      </p:sp>
+      <p:sp>
+        <p:nvSpPr>
+          <p:cNvPr id="25" name="TextBox 24"/>
           <p:cNvSpPr txBox="1"/>
           <p:nvPr/>
         </p:nvSpPr>
         <p:spPr>
           <a:xfrm>
-            <a:off x="640080" y="6291072"/>
-            <a:ext cx="6858000" cy="365760"/>
+            <a:off x="640080" y="5824728"/>
+            <a:ext cx="822960" cy="365760"/>
+          </a:xfrm>
+          <a:prstGeom prst="rect">
+            <a:avLst/>
+          </a:prstGeom>
+          <a:noFill/>
+        </p:spPr>
+        <p:txBody>
+          <a:bodyPr wrap="square" anchor="t" lIns="0" rIns="0" tIns="0" bIns="0">
+            <a:spAutoFit/>
+          </a:bodyPr>
+          <a:lstStyle/>
+          <a:p>
+            <a:pPr algn="ctr">
+              <a:lnSpc>
+                <a:spcPct val="100000"/>
+              </a:lnSpc>
+            </a:pPr>
+            <a:r>
+              <a:rPr sz="1700" b="1">
+                <a:solidFill>
+                  <a:srgbClr val="0B1220"/>
+                </a:solidFill>
+                <a:latin typeface="Microsoft YaHei"/>
+                <a:ea typeface="Microsoft YaHei"/>
+              </a:rPr>
+              <a:t>L4</a:t>
+            </a:r>
+          </a:p>
+        </p:txBody>
+      </p:sp>
+      <p:sp>
+        <p:nvSpPr>
+          <p:cNvPr id="26" name="TextBox 25"/>
+          <p:cNvSpPr txBox="1"/>
+          <p:nvPr/>
+        </p:nvSpPr>
+        <p:spPr>
+          <a:xfrm>
+            <a:off x="1691640" y="5779007"/>
+            <a:ext cx="5394960" cy="457200"/>
           </a:xfrm>
           <a:prstGeom prst="rect">
             <a:avLst/>
@@ -4420,7 +4151,336 @@
               </a:lnSpc>
             </a:pPr>
             <a:r>
-              <a:rPr sz="1400" b="1">
+              <a:rPr sz="1600" b="1">
+                <a:solidFill>
+                  <a:srgbClr val="F8FAFC"/>
+                </a:solidFill>
+                <a:latin typeface="Microsoft YaHei"/>
+                <a:ea typeface="Microsoft YaHei"/>
+              </a:rPr>
+              <a:t>每日简报 / 工作流 / 你的 Agent 方案</a:t>
+            </a:r>
+          </a:p>
+        </p:txBody>
+      </p:sp>
+      <p:sp>
+        <p:nvSpPr>
+          <p:cNvPr id="27" name="Rounded Rectangle 26"/>
+          <p:cNvSpPr/>
+          <p:nvPr/>
+        </p:nvSpPr>
+        <p:spPr>
+          <a:xfrm>
+            <a:off x="7726679" y="1234440"/>
+            <a:ext cx="3886200" cy="5074920"/>
+          </a:xfrm>
+          <a:prstGeom prst="roundRect">
+            <a:avLst>
+              <a:gd name="adj" fmla="val 10000"/>
+            </a:avLst>
+          </a:prstGeom>
+          <a:solidFill>
+            <a:srgbClr val="121C2E"/>
+          </a:solidFill>
+          <a:ln>
+            <a:noFill/>
+          </a:ln>
+        </p:spPr>
+        <p:style>
+          <a:lnRef idx="1">
+            <a:schemeClr val="accent1"/>
+          </a:lnRef>
+          <a:fillRef idx="3">
+            <a:schemeClr val="accent1"/>
+          </a:fillRef>
+          <a:effectRef idx="2">
+            <a:schemeClr val="accent1"/>
+          </a:effectRef>
+          <a:fontRef idx="minor">
+            <a:schemeClr val="lt1"/>
+          </a:fontRef>
+        </p:style>
+        <p:txBody>
+          <a:bodyPr rtlCol="0" anchor="ctr"/>
+          <a:lstStyle/>
+          <a:p>
+            <a:pPr algn="ctr"/>
+          </a:p>
+        </p:txBody>
+      </p:sp>
+      <p:sp>
+        <p:nvSpPr>
+          <p:cNvPr id="28" name="TextBox 27"/>
+          <p:cNvSpPr txBox="1"/>
+          <p:nvPr/>
+        </p:nvSpPr>
+        <p:spPr>
+          <a:xfrm>
+            <a:off x="7909560" y="1691640"/>
+            <a:ext cx="3520440" cy="1097280"/>
+          </a:xfrm>
+          <a:prstGeom prst="rect">
+            <a:avLst/>
+          </a:prstGeom>
+          <a:noFill/>
+        </p:spPr>
+        <p:txBody>
+          <a:bodyPr wrap="square" anchor="t" lIns="0" rIns="0" tIns="0" bIns="0">
+            <a:spAutoFit/>
+          </a:bodyPr>
+          <a:lstStyle/>
+          <a:p>
+            <a:pPr algn="ctr">
+              <a:lnSpc>
+                <a:spcPct val="115000"/>
+              </a:lnSpc>
+            </a:pPr>
+            <a:r>
+              <a:rPr sz="2400" b="1">
+                <a:solidFill>
+                  <a:srgbClr val="F8FAFC"/>
+                </a:solidFill>
+                <a:latin typeface="Microsoft YaHei"/>
+                <a:ea typeface="Microsoft YaHei"/>
+              </a:rPr>
+              <a:t>“我要试一试
+sjtubench”</a:t>
+            </a:r>
+          </a:p>
+        </p:txBody>
+      </p:sp>
+      <p:sp>
+        <p:nvSpPr>
+          <p:cNvPr id="29" name="TextBox 28"/>
+          <p:cNvSpPr txBox="1"/>
+          <p:nvPr/>
+        </p:nvSpPr>
+        <p:spPr>
+          <a:xfrm>
+            <a:off x="7955279" y="3063240"/>
+            <a:ext cx="3429000" cy="365760"/>
+          </a:xfrm>
+          <a:prstGeom prst="rect">
+            <a:avLst/>
+          </a:prstGeom>
+          <a:noFill/>
+        </p:spPr>
+        <p:txBody>
+          <a:bodyPr wrap="square" anchor="t" lIns="0" rIns="0" tIns="0" bIns="0">
+            <a:spAutoFit/>
+          </a:bodyPr>
+          <a:lstStyle/>
+          <a:p>
+            <a:pPr algn="ctr">
+              <a:lnSpc>
+                <a:spcPct val="100000"/>
+              </a:lnSpc>
+            </a:pPr>
+            <a:r>
+              <a:rPr sz="1400" b="0">
+                <a:solidFill>
+                  <a:srgbClr val="94A3B8"/>
+                </a:solidFill>
+                <a:latin typeface="Microsoft YaHei"/>
+                <a:ea typeface="Microsoft YaHei"/>
+              </a:rPr>
+              <a:t>登录一下 jAccount</a:t>
+            </a:r>
+          </a:p>
+        </p:txBody>
+      </p:sp>
+      <p:sp>
+        <p:nvSpPr>
+          <p:cNvPr id="30" name="TextBox 29"/>
+          <p:cNvSpPr txBox="1"/>
+          <p:nvPr/>
+        </p:nvSpPr>
+        <p:spPr>
+          <a:xfrm>
+            <a:off x="7955279" y="3502152"/>
+            <a:ext cx="3429000" cy="502920"/>
+          </a:xfrm>
+          <a:prstGeom prst="rect">
+            <a:avLst/>
+          </a:prstGeom>
+          <a:noFill/>
+        </p:spPr>
+        <p:txBody>
+          <a:bodyPr wrap="square" anchor="t" lIns="0" rIns="0" tIns="0" bIns="0">
+            <a:spAutoFit/>
+          </a:bodyPr>
+          <a:lstStyle/>
+          <a:p>
+            <a:pPr algn="ctr">
+              <a:lnSpc>
+                <a:spcPct val="100000"/>
+              </a:lnSpc>
+            </a:pPr>
+            <a:r>
+              <a:rPr sz="2800" b="1">
+                <a:solidFill>
+                  <a:srgbClr val="22D3EE"/>
+                </a:solidFill>
+                <a:latin typeface="Microsoft YaHei"/>
+                <a:ea typeface="Microsoft YaHei"/>
+              </a:rPr>
+              <a:t>↓</a:t>
+            </a:r>
+          </a:p>
+        </p:txBody>
+      </p:sp>
+      <p:sp>
+        <p:nvSpPr>
+          <p:cNvPr id="31" name="TextBox 30"/>
+          <p:cNvSpPr txBox="1"/>
+          <p:nvPr/>
+        </p:nvSpPr>
+        <p:spPr>
+          <a:xfrm>
+            <a:off x="7863840" y="4087368"/>
+            <a:ext cx="3611880" cy="731520"/>
+          </a:xfrm>
+          <a:prstGeom prst="rect">
+            <a:avLst/>
+          </a:prstGeom>
+          <a:noFill/>
+        </p:spPr>
+        <p:txBody>
+          <a:bodyPr wrap="square" anchor="t" lIns="0" rIns="0" tIns="0" bIns="0">
+            <a:spAutoFit/>
+          </a:bodyPr>
+          <a:lstStyle/>
+          <a:p>
+            <a:pPr algn="ctr">
+              <a:lnSpc>
+                <a:spcPct val="100000"/>
+              </a:lnSpc>
+            </a:pPr>
+            <a:r>
+              <a:rPr sz="2000" b="1">
+                <a:solidFill>
+                  <a:srgbClr val="F8FAFC"/>
+                </a:solidFill>
+                <a:latin typeface="Microsoft YaHei"/>
+                <a:ea typeface="Microsoft YaHei"/>
+              </a:rPr>
+              <a:t>AI 能帮我省多少时间？</a:t>
+            </a:r>
+          </a:p>
+        </p:txBody>
+      </p:sp>
+      <p:sp>
+        <p:nvSpPr>
+          <p:cNvPr id="32" name="TextBox 31"/>
+          <p:cNvSpPr txBox="1"/>
+          <p:nvPr/>
+        </p:nvSpPr>
+        <p:spPr>
+          <a:xfrm>
+            <a:off x="7863840" y="5650992"/>
+            <a:ext cx="3611880" cy="365760"/>
+          </a:xfrm>
+          <a:prstGeom prst="rect">
+            <a:avLst/>
+          </a:prstGeom>
+          <a:noFill/>
+        </p:spPr>
+        <p:txBody>
+          <a:bodyPr wrap="square" anchor="t" lIns="0" rIns="0" tIns="0" bIns="0">
+            <a:spAutoFit/>
+          </a:bodyPr>
+          <a:lstStyle/>
+          <a:p>
+            <a:pPr algn="ctr">
+              <a:lnSpc>
+                <a:spcPct val="100000"/>
+              </a:lnSpc>
+            </a:pPr>
+            <a:r>
+              <a:rPr sz="1100" b="0">
+                <a:solidFill>
+                  <a:srgbClr val="22D3EE"/>
+                </a:solidFill>
+                <a:latin typeface="Microsoft YaHei"/>
+                <a:ea typeface="Microsoft YaHei"/>
+              </a:rPr>
+              <a:t>一切隐私信息严格保存在本地</a:t>
+            </a:r>
+          </a:p>
+        </p:txBody>
+      </p:sp>
+      <p:sp>
+        <p:nvSpPr>
+          <p:cNvPr id="33" name="Rectangle 32"/>
+          <p:cNvSpPr/>
+          <p:nvPr/>
+        </p:nvSpPr>
+        <p:spPr>
+          <a:xfrm>
+            <a:off x="0" y="6400800"/>
+            <a:ext cx="12191695" cy="457200"/>
+          </a:xfrm>
+          <a:prstGeom prst="rect">
+            <a:avLst/>
+          </a:prstGeom>
+          <a:solidFill>
+            <a:srgbClr val="0F1828"/>
+          </a:solidFill>
+          <a:ln>
+            <a:noFill/>
+          </a:ln>
+        </p:spPr>
+        <p:style>
+          <a:lnRef idx="1">
+            <a:schemeClr val="accent1"/>
+          </a:lnRef>
+          <a:fillRef idx="3">
+            <a:schemeClr val="accent1"/>
+          </a:fillRef>
+          <a:effectRef idx="2">
+            <a:schemeClr val="accent1"/>
+          </a:effectRef>
+          <a:fontRef idx="minor">
+            <a:schemeClr val="lt1"/>
+          </a:fontRef>
+        </p:style>
+        <p:txBody>
+          <a:bodyPr rtlCol="0" anchor="ctr"/>
+          <a:lstStyle/>
+          <a:p>
+            <a:pPr algn="ctr"/>
+          </a:p>
+        </p:txBody>
+      </p:sp>
+      <p:sp>
+        <p:nvSpPr>
+          <p:cNvPr id="34" name="TextBox 33"/>
+          <p:cNvSpPr txBox="1"/>
+          <p:nvPr/>
+        </p:nvSpPr>
+        <p:spPr>
+          <a:xfrm>
+            <a:off x="640080" y="6510528"/>
+            <a:ext cx="6858000" cy="274320"/>
+          </a:xfrm>
+          <a:prstGeom prst="rect">
+            <a:avLst/>
+          </a:prstGeom>
+          <a:noFill/>
+        </p:spPr>
+        <p:txBody>
+          <a:bodyPr wrap="square" anchor="t" lIns="0" rIns="0" tIns="0" bIns="0">
+            <a:spAutoFit/>
+          </a:bodyPr>
+          <a:lstStyle/>
+          <a:p>
+            <a:pPr algn="l">
+              <a:lnSpc>
+                <a:spcPct val="100000"/>
+              </a:lnSpc>
+            </a:pPr>
+            <a:r>
+              <a:rPr sz="1300" b="1">
                 <a:solidFill>
                   <a:srgbClr val="F8FAFC"/>
                 </a:solidFill>
@@ -4434,14 +4494,14 @@
       </p:sp>
       <p:sp>
         <p:nvSpPr>
-          <p:cNvPr id="34" name="TextBox 33"/>
+          <p:cNvPr id="35" name="TextBox 34"/>
           <p:cNvSpPr txBox="1"/>
           <p:nvPr/>
         </p:nvSpPr>
         <p:spPr>
           <a:xfrm>
-            <a:off x="7863840" y="6309360"/>
-            <a:ext cx="3657600" cy="320040"/>
+            <a:off x="7863840" y="6528816"/>
+            <a:ext cx="3566160" cy="256032"/>
           </a:xfrm>
           <a:prstGeom prst="rect">
             <a:avLst/>
@@ -4460,7 +4520,7 @@
               </a:lnSpc>
             </a:pPr>
             <a:r>
-              <a:rPr sz="1100" b="0">
+              <a:rPr sz="1050" b="0">
                 <a:solidFill>
                   <a:srgbClr val="94A3B8"/>
                 </a:solidFill>

</xml_diff>

<commit_message>
assets: re-export user-edited 16:9 poster; link-free 3:4 poster and Xiaohongshu copy
</commit_message>
<xml_diff>
--- a/assets/sjtu-bench-poster-16x9.pptx
+++ b/assets/sjtu-bench-poster-16x9.pptx
@@ -5,9 +5,9 @@
     <p:sldMasterId id="2147483648" r:id="rId1"/>
   </p:sldMasterIdLst>
   <p:sldIdLst>
-    <p:sldId id="256" r:id="rId7"/>
+    <p:sldId id="256" r:id="rId2"/>
   </p:sldIdLst>
-  <p:sldSz cx="12191695" cy="6858000" type="screen4x3"/>
+  <p:sldSz cx="12192000" cy="6858000"/>
   <p:notesSz cx="6858000" cy="9144000"/>
   <p:defaultTextStyle>
     <a:defPPr>
@@ -104,6 +104,22 @@
       </a:defRPr>
     </a:lvl9pPr>
   </p:defaultTextStyle>
+  <p:extLst>
+    <p:ext uri="{EFAFB233-063F-42B5-8137-9DF3F51BA10A}">
+      <p15:sldGuideLst xmlns:p15="http://schemas.microsoft.com/office/powerpoint/2012/main">
+        <p15:guide id="1" orient="horz" pos="2160">
+          <p15:clr>
+            <a:srgbClr val="A4A3A4"/>
+          </p15:clr>
+        </p15:guide>
+        <p15:guide id="2" pos="2880">
+          <p15:clr>
+            <a:srgbClr val="A4A3A4"/>
+          </p15:clr>
+        </p15:guide>
+      </p15:sldGuideLst>
+    </p:ext>
+  </p:extLst>
 </p:presentation>
 </file>
 
@@ -145,10 +161,9 @@
           <a:lstStyle/>
           <a:p>
             <a:r>
-              <a:rPr lang="en-US" smtClean="0"/>
+              <a:rPr lang="en-US"/>
               <a:t>Click to edit Master title style</a:t>
             </a:r>
-            <a:endParaRPr lang="en-US"/>
           </a:p>
         </p:txBody>
       </p:sp>
@@ -264,10 +279,9 @@
           </a:lstStyle>
           <a:p>
             <a:r>
-              <a:rPr lang="en-US" smtClean="0"/>
+              <a:rPr lang="en-US"/>
               <a:t>Click to edit Master subtitle style</a:t>
             </a:r>
-            <a:endParaRPr lang="en-US"/>
           </a:p>
         </p:txBody>
       </p:sp>
@@ -288,7 +302,7 @@
           <a:p>
             <a:fld id="{5BCAD085-E8A6-8845-BD4E-CB4CCA059FC4}" type="datetimeFigureOut">
               <a:rPr lang="en-US" smtClean="0"/>
-              <a:t>1/27/13</a:t>
+              <a:t>10/19/2026</a:t>
             </a:fld>
             <a:endParaRPr lang="en-US"/>
           </a:p>
@@ -382,10 +396,9 @@
           <a:lstStyle/>
           <a:p>
             <a:r>
-              <a:rPr lang="en-US" smtClean="0"/>
+              <a:rPr lang="en-US"/>
               <a:t>Click to edit Master title style</a:t>
             </a:r>
-            <a:endParaRPr lang="en-US"/>
           </a:p>
         </p:txBody>
       </p:sp>
@@ -406,38 +419,37 @@
           <a:p>
             <a:pPr lvl="0"/>
             <a:r>
-              <a:rPr lang="en-US" smtClean="0"/>
+              <a:rPr lang="en-US"/>
               <a:t>Click to edit Master text styles</a:t>
             </a:r>
           </a:p>
           <a:p>
             <a:pPr lvl="1"/>
             <a:r>
-              <a:rPr lang="en-US" smtClean="0"/>
+              <a:rPr lang="en-US"/>
               <a:t>Second level</a:t>
             </a:r>
           </a:p>
           <a:p>
             <a:pPr lvl="2"/>
             <a:r>
-              <a:rPr lang="en-US" smtClean="0"/>
+              <a:rPr lang="en-US"/>
               <a:t>Third level</a:t>
             </a:r>
           </a:p>
           <a:p>
             <a:pPr lvl="3"/>
             <a:r>
-              <a:rPr lang="en-US" smtClean="0"/>
+              <a:rPr lang="en-US"/>
               <a:t>Fourth level</a:t>
             </a:r>
           </a:p>
           <a:p>
             <a:pPr lvl="4"/>
             <a:r>
-              <a:rPr lang="en-US" smtClean="0"/>
+              <a:rPr lang="en-US"/>
               <a:t>Fifth level</a:t>
             </a:r>
-            <a:endParaRPr lang="en-US"/>
           </a:p>
         </p:txBody>
       </p:sp>
@@ -458,7 +470,7 @@
           <a:p>
             <a:fld id="{5BCAD085-E8A6-8845-BD4E-CB4CCA059FC4}" type="datetimeFigureOut">
               <a:rPr lang="en-US" smtClean="0"/>
-              <a:t>1/27/13</a:t>
+              <a:t>10/19/2026</a:t>
             </a:fld>
             <a:endParaRPr lang="en-US"/>
           </a:p>
@@ -557,10 +569,9 @@
           <a:lstStyle/>
           <a:p>
             <a:r>
-              <a:rPr lang="en-US" smtClean="0"/>
+              <a:rPr lang="en-US"/>
               <a:t>Click to edit Master title style</a:t>
             </a:r>
-            <a:endParaRPr lang="en-US"/>
           </a:p>
         </p:txBody>
       </p:sp>
@@ -586,38 +597,37 @@
           <a:p>
             <a:pPr lvl="0"/>
             <a:r>
-              <a:rPr lang="en-US" smtClean="0"/>
+              <a:rPr lang="en-US"/>
               <a:t>Click to edit Master text styles</a:t>
             </a:r>
           </a:p>
           <a:p>
             <a:pPr lvl="1"/>
             <a:r>
-              <a:rPr lang="en-US" smtClean="0"/>
+              <a:rPr lang="en-US"/>
               <a:t>Second level</a:t>
             </a:r>
           </a:p>
           <a:p>
             <a:pPr lvl="2"/>
             <a:r>
-              <a:rPr lang="en-US" smtClean="0"/>
+              <a:rPr lang="en-US"/>
               <a:t>Third level</a:t>
             </a:r>
           </a:p>
           <a:p>
             <a:pPr lvl="3"/>
             <a:r>
-              <a:rPr lang="en-US" smtClean="0"/>
+              <a:rPr lang="en-US"/>
               <a:t>Fourth level</a:t>
             </a:r>
           </a:p>
           <a:p>
             <a:pPr lvl="4"/>
             <a:r>
-              <a:rPr lang="en-US" smtClean="0"/>
+              <a:rPr lang="en-US"/>
               <a:t>Fifth level</a:t>
             </a:r>
-            <a:endParaRPr lang="en-US"/>
           </a:p>
         </p:txBody>
       </p:sp>
@@ -638,7 +648,7 @@
           <a:p>
             <a:fld id="{5BCAD085-E8A6-8845-BD4E-CB4CCA059FC4}" type="datetimeFigureOut">
               <a:rPr lang="en-US" smtClean="0"/>
-              <a:t>1/27/13</a:t>
+              <a:t>10/19/2026</a:t>
             </a:fld>
             <a:endParaRPr lang="en-US"/>
           </a:p>
@@ -732,10 +742,9 @@
           <a:lstStyle/>
           <a:p>
             <a:r>
-              <a:rPr lang="en-US" smtClean="0"/>
+              <a:rPr lang="en-US"/>
               <a:t>Click to edit Master title style</a:t>
             </a:r>
-            <a:endParaRPr lang="en-US"/>
           </a:p>
         </p:txBody>
       </p:sp>
@@ -756,38 +765,37 @@
           <a:p>
             <a:pPr lvl="0"/>
             <a:r>
-              <a:rPr lang="en-US" smtClean="0"/>
+              <a:rPr lang="en-US"/>
               <a:t>Click to edit Master text styles</a:t>
             </a:r>
           </a:p>
           <a:p>
             <a:pPr lvl="1"/>
             <a:r>
-              <a:rPr lang="en-US" smtClean="0"/>
+              <a:rPr lang="en-US"/>
               <a:t>Second level</a:t>
             </a:r>
           </a:p>
           <a:p>
             <a:pPr lvl="2"/>
             <a:r>
-              <a:rPr lang="en-US" smtClean="0"/>
+              <a:rPr lang="en-US"/>
               <a:t>Third level</a:t>
             </a:r>
           </a:p>
           <a:p>
             <a:pPr lvl="3"/>
             <a:r>
-              <a:rPr lang="en-US" smtClean="0"/>
+              <a:rPr lang="en-US"/>
               <a:t>Fourth level</a:t>
             </a:r>
           </a:p>
           <a:p>
             <a:pPr lvl="4"/>
             <a:r>
-              <a:rPr lang="en-US" smtClean="0"/>
+              <a:rPr lang="en-US"/>
               <a:t>Fifth level</a:t>
             </a:r>
-            <a:endParaRPr lang="en-US"/>
           </a:p>
         </p:txBody>
       </p:sp>
@@ -808,7 +816,7 @@
           <a:p>
             <a:fld id="{5BCAD085-E8A6-8845-BD4E-CB4CCA059FC4}" type="datetimeFigureOut">
               <a:rPr lang="en-US" smtClean="0"/>
-              <a:t>1/27/13</a:t>
+              <a:t>10/19/2026</a:t>
             </a:fld>
             <a:endParaRPr lang="en-US"/>
           </a:p>
@@ -911,10 +919,9 @@
           </a:lstStyle>
           <a:p>
             <a:r>
-              <a:rPr lang="en-US" smtClean="0"/>
+              <a:rPr lang="en-US"/>
               <a:t>Click to edit Master title style</a:t>
             </a:r>
-            <a:endParaRPr lang="en-US"/>
           </a:p>
         </p:txBody>
       </p:sp>
@@ -1031,7 +1038,7 @@
           <a:p>
             <a:pPr lvl="0"/>
             <a:r>
-              <a:rPr lang="en-US" smtClean="0"/>
+              <a:rPr lang="en-US"/>
               <a:t>Click to edit Master text styles</a:t>
             </a:r>
           </a:p>
@@ -1054,7 +1061,7 @@
           <a:p>
             <a:fld id="{5BCAD085-E8A6-8845-BD4E-CB4CCA059FC4}" type="datetimeFigureOut">
               <a:rPr lang="en-US" smtClean="0"/>
-              <a:t>1/27/13</a:t>
+              <a:t>10/19/2026</a:t>
             </a:fld>
             <a:endParaRPr lang="en-US"/>
           </a:p>
@@ -1148,10 +1155,9 @@
           <a:lstStyle/>
           <a:p>
             <a:r>
-              <a:rPr lang="en-US" smtClean="0"/>
+              <a:rPr lang="en-US"/>
               <a:t>Click to edit Master title style</a:t>
             </a:r>
-            <a:endParaRPr lang="en-US"/>
           </a:p>
         </p:txBody>
       </p:sp>
@@ -1205,38 +1211,37 @@
           <a:p>
             <a:pPr lvl="0"/>
             <a:r>
-              <a:rPr lang="en-US" smtClean="0"/>
+              <a:rPr lang="en-US"/>
               <a:t>Click to edit Master text styles</a:t>
             </a:r>
           </a:p>
           <a:p>
             <a:pPr lvl="1"/>
             <a:r>
-              <a:rPr lang="en-US" smtClean="0"/>
+              <a:rPr lang="en-US"/>
               <a:t>Second level</a:t>
             </a:r>
           </a:p>
           <a:p>
             <a:pPr lvl="2"/>
             <a:r>
-              <a:rPr lang="en-US" smtClean="0"/>
+              <a:rPr lang="en-US"/>
               <a:t>Third level</a:t>
             </a:r>
           </a:p>
           <a:p>
             <a:pPr lvl="3"/>
             <a:r>
-              <a:rPr lang="en-US" smtClean="0"/>
+              <a:rPr lang="en-US"/>
               <a:t>Fourth level</a:t>
             </a:r>
           </a:p>
           <a:p>
             <a:pPr lvl="4"/>
             <a:r>
-              <a:rPr lang="en-US" smtClean="0"/>
+              <a:rPr lang="en-US"/>
               <a:t>Fifth level</a:t>
             </a:r>
-            <a:endParaRPr lang="en-US"/>
           </a:p>
         </p:txBody>
       </p:sp>
@@ -1290,38 +1295,37 @@
           <a:p>
             <a:pPr lvl="0"/>
             <a:r>
-              <a:rPr lang="en-US" smtClean="0"/>
+              <a:rPr lang="en-US"/>
               <a:t>Click to edit Master text styles</a:t>
             </a:r>
           </a:p>
           <a:p>
             <a:pPr lvl="1"/>
             <a:r>
-              <a:rPr lang="en-US" smtClean="0"/>
+              <a:rPr lang="en-US"/>
               <a:t>Second level</a:t>
             </a:r>
           </a:p>
           <a:p>
             <a:pPr lvl="2"/>
             <a:r>
-              <a:rPr lang="en-US" smtClean="0"/>
+              <a:rPr lang="en-US"/>
               <a:t>Third level</a:t>
             </a:r>
           </a:p>
           <a:p>
             <a:pPr lvl="3"/>
             <a:r>
-              <a:rPr lang="en-US" smtClean="0"/>
+              <a:rPr lang="en-US"/>
               <a:t>Fourth level</a:t>
             </a:r>
           </a:p>
           <a:p>
             <a:pPr lvl="4"/>
             <a:r>
-              <a:rPr lang="en-US" smtClean="0"/>
+              <a:rPr lang="en-US"/>
               <a:t>Fifth level</a:t>
             </a:r>
-            <a:endParaRPr lang="en-US"/>
           </a:p>
         </p:txBody>
       </p:sp>
@@ -1342,7 +1346,7 @@
           <a:p>
             <a:fld id="{5BCAD085-E8A6-8845-BD4E-CB4CCA059FC4}" type="datetimeFigureOut">
               <a:rPr lang="en-US" smtClean="0"/>
-              <a:t>1/27/13</a:t>
+              <a:t>10/19/2026</a:t>
             </a:fld>
             <a:endParaRPr lang="en-US"/>
           </a:p>
@@ -1440,10 +1444,9 @@
           </a:lstStyle>
           <a:p>
             <a:r>
-              <a:rPr lang="en-US" smtClean="0"/>
+              <a:rPr lang="en-US"/>
               <a:t>Click to edit Master title style</a:t>
             </a:r>
-            <a:endParaRPr lang="en-US"/>
           </a:p>
         </p:txBody>
       </p:sp>
@@ -1506,7 +1509,7 @@
           <a:p>
             <a:pPr lvl="0"/>
             <a:r>
-              <a:rPr lang="en-US" smtClean="0"/>
+              <a:rPr lang="en-US"/>
               <a:t>Click to edit Master text styles</a:t>
             </a:r>
           </a:p>
@@ -1562,38 +1565,37 @@
           <a:p>
             <a:pPr lvl="0"/>
             <a:r>
-              <a:rPr lang="en-US" smtClean="0"/>
+              <a:rPr lang="en-US"/>
               <a:t>Click to edit Master text styles</a:t>
             </a:r>
           </a:p>
           <a:p>
             <a:pPr lvl="1"/>
             <a:r>
-              <a:rPr lang="en-US" smtClean="0"/>
+              <a:rPr lang="en-US"/>
               <a:t>Second level</a:t>
             </a:r>
           </a:p>
           <a:p>
             <a:pPr lvl="2"/>
             <a:r>
-              <a:rPr lang="en-US" smtClean="0"/>
+              <a:rPr lang="en-US"/>
               <a:t>Third level</a:t>
             </a:r>
           </a:p>
           <a:p>
             <a:pPr lvl="3"/>
             <a:r>
-              <a:rPr lang="en-US" smtClean="0"/>
+              <a:rPr lang="en-US"/>
               <a:t>Fourth level</a:t>
             </a:r>
           </a:p>
           <a:p>
             <a:pPr lvl="4"/>
             <a:r>
-              <a:rPr lang="en-US" smtClean="0"/>
+              <a:rPr lang="en-US"/>
               <a:t>Fifth level</a:t>
             </a:r>
-            <a:endParaRPr lang="en-US"/>
           </a:p>
         </p:txBody>
       </p:sp>
@@ -1656,7 +1658,7 @@
           <a:p>
             <a:pPr lvl="0"/>
             <a:r>
-              <a:rPr lang="en-US" smtClean="0"/>
+              <a:rPr lang="en-US"/>
               <a:t>Click to edit Master text styles</a:t>
             </a:r>
           </a:p>
@@ -1712,38 +1714,37 @@
           <a:p>
             <a:pPr lvl="0"/>
             <a:r>
-              <a:rPr lang="en-US" smtClean="0"/>
+              <a:rPr lang="en-US"/>
               <a:t>Click to edit Master text styles</a:t>
             </a:r>
           </a:p>
           <a:p>
             <a:pPr lvl="1"/>
             <a:r>
-              <a:rPr lang="en-US" smtClean="0"/>
+              <a:rPr lang="en-US"/>
               <a:t>Second level</a:t>
             </a:r>
           </a:p>
           <a:p>
             <a:pPr lvl="2"/>
             <a:r>
-              <a:rPr lang="en-US" smtClean="0"/>
+              <a:rPr lang="en-US"/>
               <a:t>Third level</a:t>
             </a:r>
           </a:p>
           <a:p>
             <a:pPr lvl="3"/>
             <a:r>
-              <a:rPr lang="en-US" smtClean="0"/>
+              <a:rPr lang="en-US"/>
               <a:t>Fourth level</a:t>
             </a:r>
           </a:p>
           <a:p>
             <a:pPr lvl="4"/>
             <a:r>
-              <a:rPr lang="en-US" smtClean="0"/>
+              <a:rPr lang="en-US"/>
               <a:t>Fifth level</a:t>
             </a:r>
-            <a:endParaRPr lang="en-US"/>
           </a:p>
         </p:txBody>
       </p:sp>
@@ -1764,7 +1765,7 @@
           <a:p>
             <a:fld id="{5BCAD085-E8A6-8845-BD4E-CB4CCA059FC4}" type="datetimeFigureOut">
               <a:rPr lang="en-US" smtClean="0"/>
-              <a:t>1/27/13</a:t>
+              <a:t>10/19/2026</a:t>
             </a:fld>
             <a:endParaRPr lang="en-US"/>
           </a:p>
@@ -1858,10 +1859,9 @@
           <a:lstStyle/>
           <a:p>
             <a:r>
-              <a:rPr lang="en-US" smtClean="0"/>
+              <a:rPr lang="en-US"/>
               <a:t>Click to edit Master title style</a:t>
             </a:r>
-            <a:endParaRPr lang="en-US"/>
           </a:p>
         </p:txBody>
       </p:sp>
@@ -1882,7 +1882,7 @@
           <a:p>
             <a:fld id="{5BCAD085-E8A6-8845-BD4E-CB4CCA059FC4}" type="datetimeFigureOut">
               <a:rPr lang="en-US" smtClean="0"/>
-              <a:t>1/27/13</a:t>
+              <a:t>10/19/2026</a:t>
             </a:fld>
             <a:endParaRPr lang="en-US"/>
           </a:p>
@@ -1977,7 +1977,7 @@
           <a:p>
             <a:fld id="{5BCAD085-E8A6-8845-BD4E-CB4CCA059FC4}" type="datetimeFigureOut">
               <a:rPr lang="en-US" smtClean="0"/>
-              <a:t>1/27/13</a:t>
+              <a:t>10/19/2026</a:t>
             </a:fld>
             <a:endParaRPr lang="en-US"/>
           </a:p>
@@ -2080,10 +2080,9 @@
           </a:lstStyle>
           <a:p>
             <a:r>
-              <a:rPr lang="en-US" smtClean="0"/>
+              <a:rPr lang="en-US"/>
               <a:t>Click to edit Master title style</a:t>
             </a:r>
-            <a:endParaRPr lang="en-US"/>
           </a:p>
         </p:txBody>
       </p:sp>
@@ -2137,38 +2136,37 @@
           <a:p>
             <a:pPr lvl="0"/>
             <a:r>
-              <a:rPr lang="en-US" smtClean="0"/>
+              <a:rPr lang="en-US"/>
               <a:t>Click to edit Master text styles</a:t>
             </a:r>
           </a:p>
           <a:p>
             <a:pPr lvl="1"/>
             <a:r>
-              <a:rPr lang="en-US" smtClean="0"/>
+              <a:rPr lang="en-US"/>
               <a:t>Second level</a:t>
             </a:r>
           </a:p>
           <a:p>
             <a:pPr lvl="2"/>
             <a:r>
-              <a:rPr lang="en-US" smtClean="0"/>
+              <a:rPr lang="en-US"/>
               <a:t>Third level</a:t>
             </a:r>
           </a:p>
           <a:p>
             <a:pPr lvl="3"/>
             <a:r>
-              <a:rPr lang="en-US" smtClean="0"/>
+              <a:rPr lang="en-US"/>
               <a:t>Fourth level</a:t>
             </a:r>
           </a:p>
           <a:p>
             <a:pPr lvl="4"/>
             <a:r>
-              <a:rPr lang="en-US" smtClean="0"/>
+              <a:rPr lang="en-US"/>
               <a:t>Fifth level</a:t>
             </a:r>
-            <a:endParaRPr lang="en-US"/>
           </a:p>
         </p:txBody>
       </p:sp>
@@ -2231,7 +2229,7 @@
           <a:p>
             <a:pPr lvl="0"/>
             <a:r>
-              <a:rPr lang="en-US" smtClean="0"/>
+              <a:rPr lang="en-US"/>
               <a:t>Click to edit Master text styles</a:t>
             </a:r>
           </a:p>
@@ -2254,7 +2252,7 @@
           <a:p>
             <a:fld id="{5BCAD085-E8A6-8845-BD4E-CB4CCA059FC4}" type="datetimeFigureOut">
               <a:rPr lang="en-US" smtClean="0"/>
-              <a:t>1/27/13</a:t>
+              <a:t>10/19/2026</a:t>
             </a:fld>
             <a:endParaRPr lang="en-US"/>
           </a:p>
@@ -2357,10 +2355,9 @@
           </a:lstStyle>
           <a:p>
             <a:r>
-              <a:rPr lang="en-US" smtClean="0"/>
+              <a:rPr lang="en-US"/>
               <a:t>Click to edit Master title style</a:t>
             </a:r>
-            <a:endParaRPr lang="en-US"/>
           </a:p>
         </p:txBody>
       </p:sp>
@@ -2484,7 +2481,7 @@
           <a:p>
             <a:pPr lvl="0"/>
             <a:r>
-              <a:rPr lang="en-US" smtClean="0"/>
+              <a:rPr lang="en-US"/>
               <a:t>Click to edit Master text styles</a:t>
             </a:r>
           </a:p>
@@ -2507,7 +2504,7 @@
           <a:p>
             <a:fld id="{5BCAD085-E8A6-8845-BD4E-CB4CCA059FC4}" type="datetimeFigureOut">
               <a:rPr lang="en-US" smtClean="0"/>
-              <a:t>1/27/13</a:t>
+              <a:t>10/19/2026</a:t>
             </a:fld>
             <a:endParaRPr lang="en-US"/>
           </a:p>
@@ -2616,10 +2613,9 @@
           <a:lstStyle/>
           <a:p>
             <a:r>
-              <a:rPr lang="en-US" smtClean="0"/>
+              <a:rPr lang="en-US"/>
               <a:t>Click to edit Master title style</a:t>
             </a:r>
-            <a:endParaRPr lang="en-US"/>
           </a:p>
         </p:txBody>
       </p:sp>
@@ -2650,38 +2646,37 @@
           <a:p>
             <a:pPr lvl="0"/>
             <a:r>
-              <a:rPr lang="en-US" smtClean="0"/>
+              <a:rPr lang="en-US"/>
               <a:t>Click to edit Master text styles</a:t>
             </a:r>
           </a:p>
           <a:p>
             <a:pPr lvl="1"/>
             <a:r>
-              <a:rPr lang="en-US" smtClean="0"/>
+              <a:rPr lang="en-US"/>
               <a:t>Second level</a:t>
             </a:r>
           </a:p>
           <a:p>
             <a:pPr lvl="2"/>
             <a:r>
-              <a:rPr lang="en-US" smtClean="0"/>
+              <a:rPr lang="en-US"/>
               <a:t>Third level</a:t>
             </a:r>
           </a:p>
           <a:p>
             <a:pPr lvl="3"/>
             <a:r>
-              <a:rPr lang="en-US" smtClean="0"/>
+              <a:rPr lang="en-US"/>
               <a:t>Fourth level</a:t>
             </a:r>
           </a:p>
           <a:p>
             <a:pPr lvl="4"/>
             <a:r>
-              <a:rPr lang="en-US" smtClean="0"/>
+              <a:rPr lang="en-US"/>
               <a:t>Fifth level</a:t>
             </a:r>
-            <a:endParaRPr lang="en-US"/>
           </a:p>
         </p:txBody>
       </p:sp>
@@ -2720,7 +2715,7 @@
           <a:p>
             <a:fld id="{5BCAD085-E8A6-8845-BD4E-CB4CCA059FC4}" type="datetimeFigureOut">
               <a:rPr lang="en-US" smtClean="0"/>
-              <a:t>1/27/13</a:t>
+              <a:t>10/19/2026</a:t>
             </a:fld>
             <a:endParaRPr lang="en-US"/>
           </a:p>
@@ -3079,7 +3074,7 @@
 </file>
 
 <file path=ppt/slides/slide1.xml><?xml version="1.0" encoding="utf-8"?>
-<p:sld xmlns:a="http://schemas.openxmlformats.org/drawingml/2006/main" xmlns:p="http://schemas.openxmlformats.org/presentationml/2006/main" xmlns:r="http://schemas.openxmlformats.org/officeDocument/2006/relationships">
+<p:sld xmlns:a="http://schemas.openxmlformats.org/drawingml/2006/main" xmlns:r="http://schemas.openxmlformats.org/officeDocument/2006/relationships" xmlns:p="http://schemas.openxmlformats.org/presentationml/2006/main">
   <p:cSld>
     <p:bg>
       <p:bgPr>
@@ -3095,7 +3090,14 @@
         <p:cNvGrpSpPr/>
         <p:nvPr/>
       </p:nvGrpSpPr>
-      <p:grpSpPr/>
+      <p:grpSpPr>
+        <a:xfrm>
+          <a:off x="0" y="0"/>
+          <a:ext cx="0" cy="0"/>
+          <a:chOff x="0" y="0"/>
+          <a:chExt cx="0" cy="0"/>
+        </a:xfrm>
+      </p:grpSpPr>
       <p:sp>
         <p:nvSpPr>
           <p:cNvPr id="2" name="Oval 1"/>
@@ -3136,6 +3138,7 @@
           <a:lstStyle/>
           <a:p>
             <a:pPr algn="ctr"/>
+            <a:endParaRPr/>
           </a:p>
         </p:txBody>
       </p:sp>
@@ -3179,6 +3182,7 @@
           <a:lstStyle/>
           <a:p>
             <a:pPr algn="ctr"/>
+            <a:endParaRPr/>
           </a:p>
         </p:txBody>
       </p:sp>
@@ -3190,7 +3194,7 @@
         </p:nvSpPr>
         <p:spPr>
           <a:xfrm>
-            <a:off x="9601200" y="5212080"/>
+            <a:off x="9601200" y="4852852"/>
             <a:ext cx="1188720" cy="1188720"/>
           </a:xfrm>
           <a:prstGeom prst="ellipse">
@@ -3222,6 +3226,7 @@
           <a:lstStyle/>
           <a:p>
             <a:pPr algn="ctr"/>
+            <a:endParaRPr/>
           </a:p>
         </p:txBody>
       </p:sp>
@@ -3265,19 +3270,117 @@
           <a:lstStyle/>
           <a:p>
             <a:pPr algn="ctr"/>
-          </a:p>
-        </p:txBody>
-      </p:sp>
-      <p:sp>
-        <p:nvSpPr>
-          <p:cNvPr id="6" name="Rounded Rectangle 5"/>
+            <a:endParaRPr/>
+          </a:p>
+        </p:txBody>
+      </p:sp>
+      <p:sp>
+        <p:nvSpPr>
+          <p:cNvPr id="8" name="TextBox 7"/>
+          <p:cNvSpPr txBox="1"/>
+          <p:nvPr/>
+        </p:nvSpPr>
+        <p:spPr>
+          <a:xfrm>
+            <a:off x="640080" y="442831"/>
+            <a:ext cx="5509522" cy="1015663"/>
+          </a:xfrm>
+          <a:prstGeom prst="rect">
+            <a:avLst/>
+          </a:prstGeom>
+          <a:noFill/>
+        </p:spPr>
+        <p:txBody>
+          <a:bodyPr wrap="none" lIns="0" tIns="0" rIns="0" bIns="0">
+            <a:spAutoFit/>
+          </a:bodyPr>
+          <a:lstStyle/>
+          <a:p>
+            <a:r>
+              <a:rPr sz="6600" b="1" dirty="0">
+                <a:solidFill>
+                  <a:srgbClr val="F8FAFC"/>
+                </a:solidFill>
+                <a:latin typeface="Microsoft YaHei"/>
+                <a:ea typeface="Microsoft YaHei"/>
+              </a:rPr>
+              <a:t>SJTU-</a:t>
+            </a:r>
+            <a:r>
+              <a:rPr sz="6600" b="1" dirty="0">
+                <a:solidFill>
+                  <a:srgbClr val="22D3EE"/>
+                </a:solidFill>
+                <a:latin typeface="Microsoft YaHei"/>
+                <a:ea typeface="Microsoft YaHei"/>
+              </a:rPr>
+              <a:t>BENCH</a:t>
+            </a:r>
+          </a:p>
+        </p:txBody>
+      </p:sp>
+      <p:sp>
+        <p:nvSpPr>
+          <p:cNvPr id="9" name="TextBox 8"/>
+          <p:cNvSpPr txBox="1"/>
+          <p:nvPr/>
+        </p:nvSpPr>
+        <p:spPr>
+          <a:xfrm>
+            <a:off x="658368" y="1560141"/>
+            <a:ext cx="5326779" cy="615553"/>
+          </a:xfrm>
+          <a:prstGeom prst="rect">
+            <a:avLst/>
+          </a:prstGeom>
+          <a:noFill/>
+        </p:spPr>
+        <p:txBody>
+          <a:bodyPr wrap="none" lIns="0" tIns="0" rIns="0" bIns="0">
+            <a:spAutoFit/>
+          </a:bodyPr>
+          <a:lstStyle/>
+          <a:p>
+            <a:r>
+              <a:rPr sz="4000" b="1" dirty="0">
+                <a:solidFill>
+                  <a:srgbClr val="22D3EE"/>
+                </a:solidFill>
+                <a:latin typeface="Microsoft YaHei"/>
+                <a:ea typeface="Microsoft YaHei"/>
+              </a:rPr>
+              <a:t>AI </a:t>
+            </a:r>
+            <a:r>
+              <a:rPr sz="4000" b="1" dirty="0" err="1">
+                <a:solidFill>
+                  <a:srgbClr val="F8FAFC"/>
+                </a:solidFill>
+                <a:latin typeface="Microsoft YaHei"/>
+                <a:ea typeface="Microsoft YaHei"/>
+              </a:rPr>
+              <a:t>帮你掌握校园的一切</a:t>
+            </a:r>
+            <a:endParaRPr sz="4000" b="1" dirty="0">
+              <a:solidFill>
+                <a:srgbClr val="F8FAFC"/>
+              </a:solidFill>
+              <a:latin typeface="Microsoft YaHei"/>
+              <a:ea typeface="Microsoft YaHei"/>
+            </a:endParaRPr>
+          </a:p>
+        </p:txBody>
+      </p:sp>
+      <p:sp>
+        <p:nvSpPr>
+          <p:cNvPr id="11" name="Rounded Rectangle 10"/>
           <p:cNvSpPr/>
           <p:nvPr/>
         </p:nvSpPr>
         <p:spPr>
           <a:xfrm>
-            <a:off x="640080" y="457200"/>
-            <a:ext cx="2926080" cy="365760"/>
+            <a:off x="640080" y="3072384"/>
+            <a:ext cx="6629400" cy="713232"/>
           </a:xfrm>
           <a:prstGeom prst="roundRect">
             <a:avLst>
@@ -3285,7 +3388,7 @@
             </a:avLst>
           </a:prstGeom>
           <a:solidFill>
-            <a:srgbClr val="162A3C"/>
+            <a:srgbClr val="121C2E"/>
           </a:solidFill>
           <a:ln>
             <a:noFill/>
@@ -3310,189 +3413,20 @@
           <a:lstStyle/>
           <a:p>
             <a:pPr algn="ctr"/>
-          </a:p>
-        </p:txBody>
-      </p:sp>
-      <p:sp>
-        <p:nvSpPr>
-          <p:cNvPr id="7" name="TextBox 6"/>
-          <p:cNvSpPr txBox="1"/>
-          <p:nvPr/>
-        </p:nvSpPr>
-        <p:spPr>
-          <a:xfrm>
-            <a:off x="758952" y="512064"/>
-            <a:ext cx="2743200" cy="274320"/>
-          </a:xfrm>
-          <a:prstGeom prst="rect">
-            <a:avLst/>
-          </a:prstGeom>
-          <a:noFill/>
-        </p:spPr>
-        <p:txBody>
-          <a:bodyPr wrap="square" anchor="t" lIns="0" rIns="0" tIns="0" bIns="0">
-            <a:spAutoFit/>
-          </a:bodyPr>
-          <a:lstStyle/>
-          <a:p>
-            <a:pPr algn="l">
-              <a:lnSpc>
-                <a:spcPct val="100000"/>
-              </a:lnSpc>
-            </a:pPr>
-            <a:r>
-              <a:rPr sz="1050" b="1">
-                <a:solidFill>
-                  <a:srgbClr val="22D3EE"/>
-                </a:solidFill>
-                <a:latin typeface="Microsoft YaHei"/>
-                <a:ea typeface="Microsoft YaHei"/>
-              </a:rPr>
-              <a:t>SJTU · CAMPUS AI BENCH</a:t>
-            </a:r>
-          </a:p>
-        </p:txBody>
-      </p:sp>
-      <p:sp>
-        <p:nvSpPr>
-          <p:cNvPr id="8" name="TextBox 7"/>
-          <p:cNvSpPr txBox="1"/>
-          <p:nvPr/>
-        </p:nvSpPr>
-        <p:spPr>
-          <a:xfrm>
-            <a:off x="640080" y="932688"/>
-            <a:ext cx="7315200" cy="822960"/>
-          </a:xfrm>
-          <a:prstGeom prst="rect">
-            <a:avLst/>
-          </a:prstGeom>
-          <a:noFill/>
-        </p:spPr>
-        <p:txBody>
-          <a:bodyPr wrap="none" lIns="0" rIns="0" tIns="0" bIns="0">
-            <a:spAutoFit/>
-          </a:bodyPr>
-          <a:lstStyle/>
-          <a:p>
-            <a:r>
-              <a:rPr sz="5400" b="1">
-                <a:solidFill>
-                  <a:srgbClr val="F8FAFC"/>
-                </a:solidFill>
-                <a:latin typeface="Microsoft YaHei"/>
-                <a:ea typeface="Microsoft YaHei"/>
-              </a:rPr>
-              <a:t>SJTU-</a:t>
-            </a:r>
-            <a:r>
-              <a:rPr sz="5400" b="1">
-                <a:solidFill>
-                  <a:srgbClr val="22D3EE"/>
-                </a:solidFill>
-                <a:latin typeface="Microsoft YaHei"/>
-                <a:ea typeface="Microsoft YaHei"/>
-              </a:rPr>
-              <a:t>BENCH</a:t>
-            </a:r>
-          </a:p>
-        </p:txBody>
-      </p:sp>
-      <p:sp>
-        <p:nvSpPr>
-          <p:cNvPr id="9" name="TextBox 8"/>
-          <p:cNvSpPr txBox="1"/>
-          <p:nvPr/>
-        </p:nvSpPr>
-        <p:spPr>
-          <a:xfrm>
-            <a:off x="658368" y="1810512"/>
-            <a:ext cx="7498079" cy="640080"/>
-          </a:xfrm>
-          <a:prstGeom prst="rect">
-            <a:avLst/>
-          </a:prstGeom>
-          <a:noFill/>
-        </p:spPr>
-        <p:txBody>
-          <a:bodyPr wrap="none" lIns="0" rIns="0" tIns="0" bIns="0">
-            <a:spAutoFit/>
-          </a:bodyPr>
-          <a:lstStyle/>
-          <a:p>
-            <a:r>
-              <a:rPr sz="3000" b="1">
-                <a:solidFill>
-                  <a:srgbClr val="22D3EE"/>
-                </a:solidFill>
-                <a:latin typeface="Microsoft YaHei"/>
-                <a:ea typeface="Microsoft YaHei"/>
-              </a:rPr>
-              <a:t>AI </a:t>
-            </a:r>
-            <a:r>
-              <a:rPr sz="3000" b="1">
-                <a:solidFill>
-                  <a:srgbClr val="F8FAFC"/>
-                </a:solidFill>
-                <a:latin typeface="Microsoft YaHei"/>
-                <a:ea typeface="Microsoft YaHei"/>
-              </a:rPr>
-              <a:t>帮你掌握校园的一切</a:t>
-            </a:r>
-          </a:p>
-        </p:txBody>
-      </p:sp>
-      <p:sp>
-        <p:nvSpPr>
-          <p:cNvPr id="10" name="TextBox 9"/>
-          <p:cNvSpPr txBox="1"/>
-          <p:nvPr/>
-        </p:nvSpPr>
-        <p:spPr>
-          <a:xfrm>
-            <a:off x="676656" y="2487168"/>
-            <a:ext cx="7315200" cy="365760"/>
-          </a:xfrm>
-          <a:prstGeom prst="rect">
-            <a:avLst/>
-          </a:prstGeom>
-          <a:noFill/>
-        </p:spPr>
-        <p:txBody>
-          <a:bodyPr wrap="square" anchor="t" lIns="0" rIns="0" tIns="0" bIns="0">
-            <a:spAutoFit/>
-          </a:bodyPr>
-          <a:lstStyle/>
-          <a:p>
-            <a:pPr algn="l">
-              <a:lnSpc>
-                <a:spcPct val="100000"/>
-              </a:lnSpc>
-            </a:pPr>
-            <a:r>
-              <a:rPr sz="1400" b="0">
-                <a:solidFill>
-                  <a:srgbClr val="94A3B8"/>
-                </a:solidFill>
-                <a:latin typeface="Microsoft YaHei"/>
-                <a:ea typeface="Microsoft YaHei"/>
-              </a:rPr>
-              <a:t>15 个真实校园任务 · L1–L4</a:t>
-            </a:r>
-          </a:p>
-        </p:txBody>
-      </p:sp>
-      <p:sp>
-        <p:nvSpPr>
-          <p:cNvPr id="11" name="Rounded Rectangle 10"/>
+            <a:endParaRPr/>
+          </a:p>
+        </p:txBody>
+      </p:sp>
+      <p:sp>
+        <p:nvSpPr>
+          <p:cNvPr id="12" name="Rounded Rectangle 11"/>
           <p:cNvSpPr/>
           <p:nvPr/>
         </p:nvSpPr>
         <p:spPr>
           <a:xfrm>
-            <a:off x="640080" y="3072384"/>
-            <a:ext cx="6629400" cy="713232"/>
+            <a:off x="640080" y="2680498"/>
+            <a:ext cx="822960" cy="713232"/>
           </a:xfrm>
           <a:prstGeom prst="roundRect">
             <a:avLst>
@@ -3500,7 +3434,7 @@
             </a:avLst>
           </a:prstGeom>
           <a:solidFill>
-            <a:srgbClr val="121C2E"/>
+            <a:srgbClr val="A3E635"/>
           </a:solidFill>
           <a:ln>
             <a:noFill/>
@@ -3525,19 +3459,167 @@
           <a:lstStyle/>
           <a:p>
             <a:pPr algn="ctr"/>
-          </a:p>
-        </p:txBody>
-      </p:sp>
-      <p:sp>
-        <p:nvSpPr>
-          <p:cNvPr id="12" name="Rounded Rectangle 11"/>
+            <a:endParaRPr/>
+          </a:p>
+        </p:txBody>
+      </p:sp>
+      <p:sp>
+        <p:nvSpPr>
+          <p:cNvPr id="13" name="TextBox 12"/>
+          <p:cNvSpPr txBox="1"/>
+          <p:nvPr/>
+        </p:nvSpPr>
+        <p:spPr>
+          <a:xfrm>
+            <a:off x="640080" y="2854234"/>
+            <a:ext cx="822960" cy="365760"/>
+          </a:xfrm>
+          <a:prstGeom prst="rect">
+            <a:avLst/>
+          </a:prstGeom>
+          <a:noFill/>
+        </p:spPr>
+        <p:txBody>
+          <a:bodyPr wrap="square" lIns="0" tIns="0" rIns="0" bIns="0" anchor="t">
+            <a:spAutoFit/>
+          </a:bodyPr>
+          <a:lstStyle/>
+          <a:p>
+            <a:pPr algn="ctr">
+              <a:lnSpc>
+                <a:spcPct val="100000"/>
+              </a:lnSpc>
+            </a:pPr>
+            <a:r>
+              <a:rPr sz="1700" b="1">
+                <a:solidFill>
+                  <a:srgbClr val="0B1220"/>
+                </a:solidFill>
+                <a:latin typeface="Microsoft YaHei"/>
+                <a:ea typeface="Microsoft YaHei"/>
+              </a:rPr>
+              <a:t>L1</a:t>
+            </a:r>
+          </a:p>
+        </p:txBody>
+      </p:sp>
+      <p:sp>
+        <p:nvSpPr>
+          <p:cNvPr id="14" name="TextBox 13"/>
+          <p:cNvSpPr txBox="1"/>
+          <p:nvPr/>
+        </p:nvSpPr>
+        <p:spPr>
+          <a:xfrm>
+            <a:off x="1691640" y="2808514"/>
+            <a:ext cx="5394960" cy="369332"/>
+          </a:xfrm>
+          <a:prstGeom prst="rect">
+            <a:avLst/>
+          </a:prstGeom>
+          <a:noFill/>
+        </p:spPr>
+        <p:txBody>
+          <a:bodyPr wrap="square" lIns="0" tIns="0" rIns="0" bIns="0" anchor="t">
+            <a:spAutoFit/>
+          </a:bodyPr>
+          <a:lstStyle/>
+          <a:p>
+            <a:pPr algn="l">
+              <a:lnSpc>
+                <a:spcPct val="100000"/>
+              </a:lnSpc>
+            </a:pPr>
+            <a:r>
+              <a:rPr sz="2400" b="1" dirty="0" err="1">
+                <a:solidFill>
+                  <a:srgbClr val="F8FAFC"/>
+                </a:solidFill>
+                <a:latin typeface="Microsoft YaHei"/>
+                <a:ea typeface="Microsoft YaHei"/>
+              </a:rPr>
+              <a:t>查课表</a:t>
+            </a:r>
+            <a:r>
+              <a:rPr sz="2400" b="1" dirty="0">
+                <a:solidFill>
+                  <a:srgbClr val="F8FAFC"/>
+                </a:solidFill>
+                <a:latin typeface="Microsoft YaHei"/>
+                <a:ea typeface="Microsoft YaHei"/>
+              </a:rPr>
+              <a:t> / </a:t>
+            </a:r>
+            <a:r>
+              <a:rPr sz="2400" b="1" dirty="0" err="1">
+                <a:solidFill>
+                  <a:srgbClr val="F8FAFC"/>
+                </a:solidFill>
+                <a:latin typeface="Microsoft YaHei"/>
+                <a:ea typeface="Microsoft YaHei"/>
+              </a:rPr>
+              <a:t>通知</a:t>
+            </a:r>
+            <a:r>
+              <a:rPr sz="2400" b="1" dirty="0">
+                <a:solidFill>
+                  <a:srgbClr val="F8FAFC"/>
+                </a:solidFill>
+                <a:latin typeface="Microsoft YaHei"/>
+                <a:ea typeface="Microsoft YaHei"/>
+              </a:rPr>
+              <a:t> / </a:t>
+            </a:r>
+            <a:r>
+              <a:rPr sz="2400" b="1" dirty="0" err="1">
+                <a:solidFill>
+                  <a:srgbClr val="F8FAFC"/>
+                </a:solidFill>
+                <a:latin typeface="Microsoft YaHei"/>
+                <a:ea typeface="Microsoft YaHei"/>
+              </a:rPr>
+              <a:t>水源</a:t>
+            </a:r>
+            <a:r>
+              <a:rPr sz="2400" b="1" dirty="0">
+                <a:solidFill>
+                  <a:srgbClr val="F8FAFC"/>
+                </a:solidFill>
+                <a:latin typeface="Microsoft YaHei"/>
+                <a:ea typeface="Microsoft YaHei"/>
+              </a:rPr>
+              <a:t> / </a:t>
+            </a:r>
+            <a:r>
+              <a:rPr sz="2400" b="1" dirty="0" err="1">
+                <a:solidFill>
+                  <a:srgbClr val="F8FAFC"/>
+                </a:solidFill>
+                <a:latin typeface="Microsoft YaHei"/>
+                <a:ea typeface="Microsoft YaHei"/>
+              </a:rPr>
+              <a:t>交我办</a:t>
+            </a:r>
+            <a:endParaRPr sz="2400" b="1" dirty="0">
+              <a:solidFill>
+                <a:srgbClr val="F8FAFC"/>
+              </a:solidFill>
+              <a:latin typeface="Microsoft YaHei"/>
+              <a:ea typeface="Microsoft YaHei"/>
+            </a:endParaRPr>
+          </a:p>
+        </p:txBody>
+      </p:sp>
+      <p:sp>
+        <p:nvSpPr>
+          <p:cNvPr id="15" name="Rounded Rectangle 14"/>
           <p:cNvSpPr/>
           <p:nvPr/>
         </p:nvSpPr>
         <p:spPr>
           <a:xfrm>
-            <a:off x="640080" y="3072384"/>
-            <a:ext cx="822960" cy="713232"/>
+            <a:off x="640080" y="3931920"/>
+            <a:ext cx="6629400" cy="713232"/>
           </a:xfrm>
           <a:prstGeom prst="roundRect">
             <a:avLst>
@@ -3545,7 +3627,7 @@
             </a:avLst>
           </a:prstGeom>
           <a:solidFill>
-            <a:srgbClr val="A3E635"/>
+            <a:srgbClr val="121C2E"/>
           </a:solidFill>
           <a:ln>
             <a:noFill/>
@@ -3570,99 +3652,20 @@
           <a:lstStyle/>
           <a:p>
             <a:pPr algn="ctr"/>
-          </a:p>
-        </p:txBody>
-      </p:sp>
-      <p:sp>
-        <p:nvSpPr>
-          <p:cNvPr id="13" name="TextBox 12"/>
-          <p:cNvSpPr txBox="1"/>
-          <p:nvPr/>
-        </p:nvSpPr>
-        <p:spPr>
-          <a:xfrm>
-            <a:off x="640080" y="3246120"/>
-            <a:ext cx="822960" cy="365760"/>
-          </a:xfrm>
-          <a:prstGeom prst="rect">
-            <a:avLst/>
-          </a:prstGeom>
-          <a:noFill/>
-        </p:spPr>
-        <p:txBody>
-          <a:bodyPr wrap="square" anchor="t" lIns="0" rIns="0" tIns="0" bIns="0">
-            <a:spAutoFit/>
-          </a:bodyPr>
-          <a:lstStyle/>
-          <a:p>
-            <a:pPr algn="ctr">
-              <a:lnSpc>
-                <a:spcPct val="100000"/>
-              </a:lnSpc>
-            </a:pPr>
-            <a:r>
-              <a:rPr sz="1700" b="1">
-                <a:solidFill>
-                  <a:srgbClr val="0B1220"/>
-                </a:solidFill>
-                <a:latin typeface="Microsoft YaHei"/>
-                <a:ea typeface="Microsoft YaHei"/>
-              </a:rPr>
-              <a:t>L1</a:t>
-            </a:r>
-          </a:p>
-        </p:txBody>
-      </p:sp>
-      <p:sp>
-        <p:nvSpPr>
-          <p:cNvPr id="14" name="TextBox 13"/>
-          <p:cNvSpPr txBox="1"/>
-          <p:nvPr/>
-        </p:nvSpPr>
-        <p:spPr>
-          <a:xfrm>
-            <a:off x="1691640" y="3200400"/>
-            <a:ext cx="5394960" cy="457200"/>
-          </a:xfrm>
-          <a:prstGeom prst="rect">
-            <a:avLst/>
-          </a:prstGeom>
-          <a:noFill/>
-        </p:spPr>
-        <p:txBody>
-          <a:bodyPr wrap="square" anchor="t" lIns="0" rIns="0" tIns="0" bIns="0">
-            <a:spAutoFit/>
-          </a:bodyPr>
-          <a:lstStyle/>
-          <a:p>
-            <a:pPr algn="l">
-              <a:lnSpc>
-                <a:spcPct val="100000"/>
-              </a:lnSpc>
-            </a:pPr>
-            <a:r>
-              <a:rPr sz="1600" b="1">
-                <a:solidFill>
-                  <a:srgbClr val="F8FAFC"/>
-                </a:solidFill>
-                <a:latin typeface="Microsoft YaHei"/>
-                <a:ea typeface="Microsoft YaHei"/>
-              </a:rPr>
-              <a:t>查课表 / 通知 / 水源 / 交我办</a:t>
-            </a:r>
-          </a:p>
-        </p:txBody>
-      </p:sp>
-      <p:sp>
-        <p:nvSpPr>
-          <p:cNvPr id="15" name="Rounded Rectangle 14"/>
+            <a:endParaRPr/>
+          </a:p>
+        </p:txBody>
+      </p:sp>
+      <p:sp>
+        <p:nvSpPr>
+          <p:cNvPr id="16" name="Rounded Rectangle 15"/>
           <p:cNvSpPr/>
           <p:nvPr/>
         </p:nvSpPr>
         <p:spPr>
           <a:xfrm>
-            <a:off x="640080" y="3931920"/>
-            <a:ext cx="6629400" cy="713232"/>
+            <a:off x="640080" y="3540034"/>
+            <a:ext cx="822960" cy="713232"/>
           </a:xfrm>
           <a:prstGeom prst="roundRect">
             <a:avLst>
@@ -3670,7 +3673,7 @@
             </a:avLst>
           </a:prstGeom>
           <a:solidFill>
-            <a:srgbClr val="121C2E"/>
+            <a:srgbClr val="22D3EE"/>
           </a:solidFill>
           <a:ln>
             <a:noFill/>
@@ -3695,19 +3698,157 @@
           <a:lstStyle/>
           <a:p>
             <a:pPr algn="ctr"/>
-          </a:p>
-        </p:txBody>
-      </p:sp>
-      <p:sp>
-        <p:nvSpPr>
-          <p:cNvPr id="16" name="Rounded Rectangle 15"/>
+            <a:endParaRPr/>
+          </a:p>
+        </p:txBody>
+      </p:sp>
+      <p:sp>
+        <p:nvSpPr>
+          <p:cNvPr id="17" name="TextBox 16"/>
+          <p:cNvSpPr txBox="1"/>
+          <p:nvPr/>
+        </p:nvSpPr>
+        <p:spPr>
+          <a:xfrm>
+            <a:off x="640080" y="3713770"/>
+            <a:ext cx="822960" cy="365760"/>
+          </a:xfrm>
+          <a:prstGeom prst="rect">
+            <a:avLst/>
+          </a:prstGeom>
+          <a:noFill/>
+        </p:spPr>
+        <p:txBody>
+          <a:bodyPr wrap="square" lIns="0" tIns="0" rIns="0" bIns="0" anchor="t">
+            <a:spAutoFit/>
+          </a:bodyPr>
+          <a:lstStyle/>
+          <a:p>
+            <a:pPr algn="ctr">
+              <a:lnSpc>
+                <a:spcPct val="100000"/>
+              </a:lnSpc>
+            </a:pPr>
+            <a:r>
+              <a:rPr sz="1700" b="1">
+                <a:solidFill>
+                  <a:srgbClr val="0B1220"/>
+                </a:solidFill>
+                <a:latin typeface="Microsoft YaHei"/>
+                <a:ea typeface="Microsoft YaHei"/>
+              </a:rPr>
+              <a:t>L2</a:t>
+            </a:r>
+          </a:p>
+        </p:txBody>
+      </p:sp>
+      <p:sp>
+        <p:nvSpPr>
+          <p:cNvPr id="18" name="TextBox 17"/>
+          <p:cNvSpPr txBox="1"/>
+          <p:nvPr/>
+        </p:nvSpPr>
+        <p:spPr>
+          <a:xfrm>
+            <a:off x="1691640" y="3668049"/>
+            <a:ext cx="5394960" cy="369332"/>
+          </a:xfrm>
+          <a:prstGeom prst="rect">
+            <a:avLst/>
+          </a:prstGeom>
+          <a:noFill/>
+        </p:spPr>
+        <p:txBody>
+          <a:bodyPr wrap="square" lIns="0" tIns="0" rIns="0" bIns="0" anchor="t">
+            <a:spAutoFit/>
+          </a:bodyPr>
+          <a:lstStyle/>
+          <a:p>
+            <a:pPr algn="l">
+              <a:lnSpc>
+                <a:spcPct val="100000"/>
+              </a:lnSpc>
+            </a:pPr>
+            <a:r>
+              <a:rPr sz="2400" b="1" dirty="0">
+                <a:solidFill>
+                  <a:srgbClr val="F8FAFC"/>
+                </a:solidFill>
+                <a:latin typeface="Microsoft YaHei"/>
+                <a:ea typeface="Microsoft YaHei"/>
+              </a:rPr>
+              <a:t>DDL / </a:t>
+            </a:r>
+            <a:r>
+              <a:rPr sz="2400" b="1" dirty="0" err="1">
+                <a:solidFill>
+                  <a:srgbClr val="F8FAFC"/>
+                </a:solidFill>
+                <a:latin typeface="Microsoft YaHei"/>
+                <a:ea typeface="Microsoft YaHei"/>
+              </a:rPr>
+              <a:t>公众号</a:t>
+            </a:r>
+            <a:r>
+              <a:rPr sz="2400" b="1" dirty="0">
+                <a:solidFill>
+                  <a:srgbClr val="F8FAFC"/>
+                </a:solidFill>
+                <a:latin typeface="Microsoft YaHei"/>
+                <a:ea typeface="Microsoft YaHei"/>
+              </a:rPr>
+              <a:t> / </a:t>
+            </a:r>
+            <a:r>
+              <a:rPr sz="2400" b="1" dirty="0" err="1">
+                <a:solidFill>
+                  <a:srgbClr val="F8FAFC"/>
+                </a:solidFill>
+                <a:latin typeface="Microsoft YaHei"/>
+                <a:ea typeface="Microsoft YaHei"/>
+              </a:rPr>
+              <a:t>邮箱</a:t>
+            </a:r>
+            <a:r>
+              <a:rPr sz="2400" b="1" dirty="0">
+                <a:solidFill>
+                  <a:srgbClr val="F8FAFC"/>
+                </a:solidFill>
+                <a:latin typeface="Microsoft YaHei"/>
+                <a:ea typeface="Microsoft YaHei"/>
+              </a:rPr>
+              <a:t> / </a:t>
+            </a:r>
+            <a:r>
+              <a:rPr sz="2400" b="1" dirty="0" err="1">
+                <a:solidFill>
+                  <a:srgbClr val="F8FAFC"/>
+                </a:solidFill>
+                <a:latin typeface="Microsoft YaHei"/>
+                <a:ea typeface="Microsoft YaHei"/>
+              </a:rPr>
+              <a:t>活动</a:t>
+            </a:r>
+            <a:endParaRPr sz="2400" b="1" dirty="0">
+              <a:solidFill>
+                <a:srgbClr val="F8FAFC"/>
+              </a:solidFill>
+              <a:latin typeface="Microsoft YaHei"/>
+              <a:ea typeface="Microsoft YaHei"/>
+            </a:endParaRPr>
+          </a:p>
+        </p:txBody>
+      </p:sp>
+      <p:sp>
+        <p:nvSpPr>
+          <p:cNvPr id="19" name="Rounded Rectangle 18"/>
           <p:cNvSpPr/>
           <p:nvPr/>
         </p:nvSpPr>
         <p:spPr>
           <a:xfrm>
-            <a:off x="640080" y="3931920"/>
-            <a:ext cx="822960" cy="713232"/>
+            <a:off x="640080" y="4791456"/>
+            <a:ext cx="6629400" cy="713232"/>
           </a:xfrm>
           <a:prstGeom prst="roundRect">
             <a:avLst>
@@ -3715,7 +3856,7 @@
             </a:avLst>
           </a:prstGeom>
           <a:solidFill>
-            <a:srgbClr val="22D3EE"/>
+            <a:srgbClr val="121C2E"/>
           </a:solidFill>
           <a:ln>
             <a:noFill/>
@@ -3740,99 +3881,20 @@
           <a:lstStyle/>
           <a:p>
             <a:pPr algn="ctr"/>
-          </a:p>
-        </p:txBody>
-      </p:sp>
-      <p:sp>
-        <p:nvSpPr>
-          <p:cNvPr id="17" name="TextBox 16"/>
-          <p:cNvSpPr txBox="1"/>
-          <p:nvPr/>
-        </p:nvSpPr>
-        <p:spPr>
-          <a:xfrm>
-            <a:off x="640080" y="4105656"/>
-            <a:ext cx="822960" cy="365760"/>
-          </a:xfrm>
-          <a:prstGeom prst="rect">
-            <a:avLst/>
-          </a:prstGeom>
-          <a:noFill/>
-        </p:spPr>
-        <p:txBody>
-          <a:bodyPr wrap="square" anchor="t" lIns="0" rIns="0" tIns="0" bIns="0">
-            <a:spAutoFit/>
-          </a:bodyPr>
-          <a:lstStyle/>
-          <a:p>
-            <a:pPr algn="ctr">
-              <a:lnSpc>
-                <a:spcPct val="100000"/>
-              </a:lnSpc>
-            </a:pPr>
-            <a:r>
-              <a:rPr sz="1700" b="1">
-                <a:solidFill>
-                  <a:srgbClr val="0B1220"/>
-                </a:solidFill>
-                <a:latin typeface="Microsoft YaHei"/>
-                <a:ea typeface="Microsoft YaHei"/>
-              </a:rPr>
-              <a:t>L2</a:t>
-            </a:r>
-          </a:p>
-        </p:txBody>
-      </p:sp>
-      <p:sp>
-        <p:nvSpPr>
-          <p:cNvPr id="18" name="TextBox 17"/>
-          <p:cNvSpPr txBox="1"/>
-          <p:nvPr/>
-        </p:nvSpPr>
-        <p:spPr>
-          <a:xfrm>
-            <a:off x="1691640" y="4059935"/>
-            <a:ext cx="5394960" cy="457200"/>
-          </a:xfrm>
-          <a:prstGeom prst="rect">
-            <a:avLst/>
-          </a:prstGeom>
-          <a:noFill/>
-        </p:spPr>
-        <p:txBody>
-          <a:bodyPr wrap="square" anchor="t" lIns="0" rIns="0" tIns="0" bIns="0">
-            <a:spAutoFit/>
-          </a:bodyPr>
-          <a:lstStyle/>
-          <a:p>
-            <a:pPr algn="l">
-              <a:lnSpc>
-                <a:spcPct val="100000"/>
-              </a:lnSpc>
-            </a:pPr>
-            <a:r>
-              <a:rPr sz="1600" b="1">
-                <a:solidFill>
-                  <a:srgbClr val="F8FAFC"/>
-                </a:solidFill>
-                <a:latin typeface="Microsoft YaHei"/>
-                <a:ea typeface="Microsoft YaHei"/>
-              </a:rPr>
-              <a:t>DDL / 公众号 / 邮箱 / 活动</a:t>
-            </a:r>
-          </a:p>
-        </p:txBody>
-      </p:sp>
-      <p:sp>
-        <p:nvSpPr>
-          <p:cNvPr id="19" name="Rounded Rectangle 18"/>
+            <a:endParaRPr/>
+          </a:p>
+        </p:txBody>
+      </p:sp>
+      <p:sp>
+        <p:nvSpPr>
+          <p:cNvPr id="20" name="Rounded Rectangle 19"/>
           <p:cNvSpPr/>
           <p:nvPr/>
         </p:nvSpPr>
         <p:spPr>
           <a:xfrm>
-            <a:off x="640080" y="4791456"/>
-            <a:ext cx="6629400" cy="713232"/>
+            <a:off x="640080" y="4399570"/>
+            <a:ext cx="822960" cy="713232"/>
           </a:xfrm>
           <a:prstGeom prst="roundRect">
             <a:avLst>
@@ -3840,7 +3902,7 @@
             </a:avLst>
           </a:prstGeom>
           <a:solidFill>
-            <a:srgbClr val="121C2E"/>
+            <a:srgbClr val="FB923C"/>
           </a:solidFill>
           <a:ln>
             <a:noFill/>
@@ -3865,19 +3927,150 @@
           <a:lstStyle/>
           <a:p>
             <a:pPr algn="ctr"/>
-          </a:p>
-        </p:txBody>
-      </p:sp>
-      <p:sp>
-        <p:nvSpPr>
-          <p:cNvPr id="20" name="Rounded Rectangle 19"/>
+            <a:endParaRPr/>
+          </a:p>
+        </p:txBody>
+      </p:sp>
+      <p:sp>
+        <p:nvSpPr>
+          <p:cNvPr id="21" name="TextBox 20"/>
+          <p:cNvSpPr txBox="1"/>
+          <p:nvPr/>
+        </p:nvSpPr>
+        <p:spPr>
+          <a:xfrm>
+            <a:off x="640080" y="4573306"/>
+            <a:ext cx="822960" cy="365760"/>
+          </a:xfrm>
+          <a:prstGeom prst="rect">
+            <a:avLst/>
+          </a:prstGeom>
+          <a:noFill/>
+        </p:spPr>
+        <p:txBody>
+          <a:bodyPr wrap="square" lIns="0" tIns="0" rIns="0" bIns="0" anchor="t">
+            <a:spAutoFit/>
+          </a:bodyPr>
+          <a:lstStyle/>
+          <a:p>
+            <a:pPr algn="ctr">
+              <a:lnSpc>
+                <a:spcPct val="100000"/>
+              </a:lnSpc>
+            </a:pPr>
+            <a:r>
+              <a:rPr sz="1700" b="1">
+                <a:solidFill>
+                  <a:srgbClr val="0B1220"/>
+                </a:solidFill>
+                <a:latin typeface="Microsoft YaHei"/>
+                <a:ea typeface="Microsoft YaHei"/>
+              </a:rPr>
+              <a:t>L3</a:t>
+            </a:r>
+          </a:p>
+        </p:txBody>
+      </p:sp>
+      <p:sp>
+        <p:nvSpPr>
+          <p:cNvPr id="22" name="TextBox 21"/>
+          <p:cNvSpPr txBox="1"/>
+          <p:nvPr/>
+        </p:nvSpPr>
+        <p:spPr>
+          <a:xfrm>
+            <a:off x="1691640" y="4527586"/>
+            <a:ext cx="5394960" cy="369332"/>
+          </a:xfrm>
+          <a:prstGeom prst="rect">
+            <a:avLst/>
+          </a:prstGeom>
+          <a:noFill/>
+        </p:spPr>
+        <p:txBody>
+          <a:bodyPr wrap="square" lIns="0" tIns="0" rIns="0" bIns="0" anchor="t">
+            <a:spAutoFit/>
+          </a:bodyPr>
+          <a:lstStyle/>
+          <a:p>
+            <a:pPr algn="l">
+              <a:lnSpc>
+                <a:spcPct val="100000"/>
+              </a:lnSpc>
+            </a:pPr>
+            <a:r>
+              <a:rPr sz="2400" b="1" dirty="0" err="1">
+                <a:solidFill>
+                  <a:srgbClr val="F8FAFC"/>
+                </a:solidFill>
+                <a:latin typeface="Microsoft YaHei"/>
+                <a:ea typeface="Microsoft YaHei"/>
+              </a:rPr>
+              <a:t>政务流程</a:t>
+            </a:r>
+            <a:r>
+              <a:rPr sz="2400" b="1" dirty="0">
+                <a:solidFill>
+                  <a:srgbClr val="F8FAFC"/>
+                </a:solidFill>
+                <a:latin typeface="Microsoft YaHei"/>
+                <a:ea typeface="Microsoft YaHei"/>
+              </a:rPr>
+              <a:t> / </a:t>
+            </a:r>
+            <a:r>
+              <a:rPr sz="2400" b="1" dirty="0" err="1">
+                <a:solidFill>
+                  <a:srgbClr val="F8FAFC"/>
+                </a:solidFill>
+                <a:latin typeface="Microsoft YaHei"/>
+                <a:ea typeface="Microsoft YaHei"/>
+              </a:rPr>
+              <a:t>云盘</a:t>
+            </a:r>
+            <a:r>
+              <a:rPr sz="2400" b="1" dirty="0">
+                <a:solidFill>
+                  <a:srgbClr val="F8FAFC"/>
+                </a:solidFill>
+                <a:latin typeface="Microsoft YaHei"/>
+                <a:ea typeface="Microsoft YaHei"/>
+              </a:rPr>
+              <a:t> / </a:t>
+            </a:r>
+            <a:r>
+              <a:rPr sz="2400" b="1" dirty="0" err="1">
+                <a:solidFill>
+                  <a:srgbClr val="F8FAFC"/>
+                </a:solidFill>
+                <a:latin typeface="Microsoft YaHei"/>
+                <a:ea typeface="Microsoft YaHei"/>
+              </a:rPr>
+              <a:t>报销（只预填</a:t>
+            </a:r>
+            <a:r>
+              <a:rPr sz="2400" b="1" dirty="0">
+                <a:solidFill>
+                  <a:srgbClr val="F8FAFC"/>
+                </a:solidFill>
+                <a:latin typeface="Microsoft YaHei"/>
+                <a:ea typeface="Microsoft YaHei"/>
+              </a:rPr>
+              <a:t>）</a:t>
+            </a:r>
+          </a:p>
+        </p:txBody>
+      </p:sp>
+      <p:sp>
+        <p:nvSpPr>
+          <p:cNvPr id="23" name="Rounded Rectangle 22"/>
           <p:cNvSpPr/>
           <p:nvPr/>
         </p:nvSpPr>
         <p:spPr>
           <a:xfrm>
-            <a:off x="640080" y="4791456"/>
-            <a:ext cx="822960" cy="713232"/>
+            <a:off x="640080" y="5650992"/>
+            <a:ext cx="6629400" cy="713232"/>
           </a:xfrm>
           <a:prstGeom prst="roundRect">
             <a:avLst>
@@ -3885,7 +4078,7 @@
             </a:avLst>
           </a:prstGeom>
           <a:solidFill>
-            <a:srgbClr val="FB923C"/>
+            <a:srgbClr val="121C2E"/>
           </a:solidFill>
           <a:ln>
             <a:noFill/>
@@ -3910,99 +4103,20 @@
           <a:lstStyle/>
           <a:p>
             <a:pPr algn="ctr"/>
-          </a:p>
-        </p:txBody>
-      </p:sp>
-      <p:sp>
-        <p:nvSpPr>
-          <p:cNvPr id="21" name="TextBox 20"/>
-          <p:cNvSpPr txBox="1"/>
-          <p:nvPr/>
-        </p:nvSpPr>
-        <p:spPr>
-          <a:xfrm>
-            <a:off x="640080" y="4965192"/>
-            <a:ext cx="822960" cy="365760"/>
-          </a:xfrm>
-          <a:prstGeom prst="rect">
-            <a:avLst/>
-          </a:prstGeom>
-          <a:noFill/>
-        </p:spPr>
-        <p:txBody>
-          <a:bodyPr wrap="square" anchor="t" lIns="0" rIns="0" tIns="0" bIns="0">
-            <a:spAutoFit/>
-          </a:bodyPr>
-          <a:lstStyle/>
-          <a:p>
-            <a:pPr algn="ctr">
-              <a:lnSpc>
-                <a:spcPct val="100000"/>
-              </a:lnSpc>
-            </a:pPr>
-            <a:r>
-              <a:rPr sz="1700" b="1">
-                <a:solidFill>
-                  <a:srgbClr val="0B1220"/>
-                </a:solidFill>
-                <a:latin typeface="Microsoft YaHei"/>
-                <a:ea typeface="Microsoft YaHei"/>
-              </a:rPr>
-              <a:t>L3</a:t>
-            </a:r>
-          </a:p>
-        </p:txBody>
-      </p:sp>
-      <p:sp>
-        <p:nvSpPr>
-          <p:cNvPr id="22" name="TextBox 21"/>
-          <p:cNvSpPr txBox="1"/>
-          <p:nvPr/>
-        </p:nvSpPr>
-        <p:spPr>
-          <a:xfrm>
-            <a:off x="1691640" y="4919472"/>
-            <a:ext cx="5394960" cy="457200"/>
-          </a:xfrm>
-          <a:prstGeom prst="rect">
-            <a:avLst/>
-          </a:prstGeom>
-          <a:noFill/>
-        </p:spPr>
-        <p:txBody>
-          <a:bodyPr wrap="square" anchor="t" lIns="0" rIns="0" tIns="0" bIns="0">
-            <a:spAutoFit/>
-          </a:bodyPr>
-          <a:lstStyle/>
-          <a:p>
-            <a:pPr algn="l">
-              <a:lnSpc>
-                <a:spcPct val="100000"/>
-              </a:lnSpc>
-            </a:pPr>
-            <a:r>
-              <a:rPr sz="1600" b="1">
-                <a:solidFill>
-                  <a:srgbClr val="F8FAFC"/>
-                </a:solidFill>
-                <a:latin typeface="Microsoft YaHei"/>
-                <a:ea typeface="Microsoft YaHei"/>
-              </a:rPr>
-              <a:t>政务流程 / 云盘 / 报销（只预填）</a:t>
-            </a:r>
-          </a:p>
-        </p:txBody>
-      </p:sp>
-      <p:sp>
-        <p:nvSpPr>
-          <p:cNvPr id="23" name="Rounded Rectangle 22"/>
+            <a:endParaRPr/>
+          </a:p>
+        </p:txBody>
+      </p:sp>
+      <p:sp>
+        <p:nvSpPr>
+          <p:cNvPr id="24" name="Rounded Rectangle 23"/>
           <p:cNvSpPr/>
           <p:nvPr/>
         </p:nvSpPr>
         <p:spPr>
           <a:xfrm>
-            <a:off x="640080" y="5650992"/>
-            <a:ext cx="6629400" cy="713232"/>
+            <a:off x="640080" y="5259106"/>
+            <a:ext cx="822960" cy="713232"/>
           </a:xfrm>
           <a:prstGeom prst="roundRect">
             <a:avLst>
@@ -4010,7 +4124,7 @@
             </a:avLst>
           </a:prstGeom>
           <a:solidFill>
-            <a:srgbClr val="121C2E"/>
+            <a:srgbClr val="C4B5FD"/>
           </a:solidFill>
           <a:ln>
             <a:noFill/>
@@ -4035,19 +4149,167 @@
           <a:lstStyle/>
           <a:p>
             <a:pPr algn="ctr"/>
-          </a:p>
-        </p:txBody>
-      </p:sp>
-      <p:sp>
-        <p:nvSpPr>
-          <p:cNvPr id="24" name="Rounded Rectangle 23"/>
+            <a:endParaRPr/>
+          </a:p>
+        </p:txBody>
+      </p:sp>
+      <p:sp>
+        <p:nvSpPr>
+          <p:cNvPr id="25" name="TextBox 24"/>
+          <p:cNvSpPr txBox="1"/>
+          <p:nvPr/>
+        </p:nvSpPr>
+        <p:spPr>
+          <a:xfrm>
+            <a:off x="640080" y="5432842"/>
+            <a:ext cx="822960" cy="365760"/>
+          </a:xfrm>
+          <a:prstGeom prst="rect">
+            <a:avLst/>
+          </a:prstGeom>
+          <a:noFill/>
+        </p:spPr>
+        <p:txBody>
+          <a:bodyPr wrap="square" lIns="0" tIns="0" rIns="0" bIns="0" anchor="t">
+            <a:spAutoFit/>
+          </a:bodyPr>
+          <a:lstStyle/>
+          <a:p>
+            <a:pPr algn="ctr">
+              <a:lnSpc>
+                <a:spcPct val="100000"/>
+              </a:lnSpc>
+            </a:pPr>
+            <a:r>
+              <a:rPr sz="1700" b="1">
+                <a:solidFill>
+                  <a:srgbClr val="0B1220"/>
+                </a:solidFill>
+                <a:latin typeface="Microsoft YaHei"/>
+                <a:ea typeface="Microsoft YaHei"/>
+              </a:rPr>
+              <a:t>L4</a:t>
+            </a:r>
+          </a:p>
+        </p:txBody>
+      </p:sp>
+      <p:sp>
+        <p:nvSpPr>
+          <p:cNvPr id="26" name="TextBox 25"/>
+          <p:cNvSpPr txBox="1"/>
+          <p:nvPr/>
+        </p:nvSpPr>
+        <p:spPr>
+          <a:xfrm>
+            <a:off x="1691640" y="5387121"/>
+            <a:ext cx="5394960" cy="369332"/>
+          </a:xfrm>
+          <a:prstGeom prst="rect">
+            <a:avLst/>
+          </a:prstGeom>
+          <a:noFill/>
+        </p:spPr>
+        <p:txBody>
+          <a:bodyPr wrap="square" lIns="0" tIns="0" rIns="0" bIns="0" anchor="t">
+            <a:spAutoFit/>
+          </a:bodyPr>
+          <a:lstStyle/>
+          <a:p>
+            <a:pPr algn="l">
+              <a:lnSpc>
+                <a:spcPct val="100000"/>
+              </a:lnSpc>
+            </a:pPr>
+            <a:r>
+              <a:rPr sz="2400" b="1" dirty="0" err="1">
+                <a:solidFill>
+                  <a:srgbClr val="F8FAFC"/>
+                </a:solidFill>
+                <a:latin typeface="Microsoft YaHei"/>
+                <a:ea typeface="Microsoft YaHei"/>
+              </a:rPr>
+              <a:t>每日简报</a:t>
+            </a:r>
+            <a:r>
+              <a:rPr sz="2400" b="1" dirty="0">
+                <a:solidFill>
+                  <a:srgbClr val="F8FAFC"/>
+                </a:solidFill>
+                <a:latin typeface="Microsoft YaHei"/>
+                <a:ea typeface="Microsoft YaHei"/>
+              </a:rPr>
+              <a:t> / </a:t>
+            </a:r>
+            <a:r>
+              <a:rPr sz="2400" b="1" dirty="0" err="1">
+                <a:solidFill>
+                  <a:srgbClr val="F8FAFC"/>
+                </a:solidFill>
+                <a:latin typeface="Microsoft YaHei"/>
+                <a:ea typeface="Microsoft YaHei"/>
+              </a:rPr>
+              <a:t>工作流</a:t>
+            </a:r>
+            <a:r>
+              <a:rPr sz="2400" b="1" dirty="0">
+                <a:solidFill>
+                  <a:srgbClr val="F8FAFC"/>
+                </a:solidFill>
+                <a:latin typeface="Microsoft YaHei"/>
+                <a:ea typeface="Microsoft YaHei"/>
+              </a:rPr>
+              <a:t> / </a:t>
+            </a:r>
+            <a:r>
+              <a:rPr sz="2400" b="1" dirty="0" err="1">
+                <a:solidFill>
+                  <a:srgbClr val="F8FAFC"/>
+                </a:solidFill>
+                <a:latin typeface="Microsoft YaHei"/>
+                <a:ea typeface="Microsoft YaHei"/>
+              </a:rPr>
+              <a:t>你的</a:t>
+            </a:r>
+            <a:r>
+              <a:rPr sz="2400" b="1" dirty="0">
+                <a:solidFill>
+                  <a:srgbClr val="F8FAFC"/>
+                </a:solidFill>
+                <a:latin typeface="Microsoft YaHei"/>
+                <a:ea typeface="Microsoft YaHei"/>
+              </a:rPr>
+              <a:t> Agent </a:t>
+            </a:r>
+            <a:r>
+              <a:rPr sz="2400" b="1" dirty="0" err="1">
+                <a:solidFill>
+                  <a:srgbClr val="F8FAFC"/>
+                </a:solidFill>
+                <a:latin typeface="Microsoft YaHei"/>
+                <a:ea typeface="Microsoft YaHei"/>
+              </a:rPr>
+              <a:t>方案</a:t>
+            </a:r>
+            <a:endParaRPr sz="2400" b="1" dirty="0">
+              <a:solidFill>
+                <a:srgbClr val="F8FAFC"/>
+              </a:solidFill>
+              <a:latin typeface="Microsoft YaHei"/>
+              <a:ea typeface="Microsoft YaHei"/>
+            </a:endParaRPr>
+          </a:p>
+        </p:txBody>
+      </p:sp>
+      <p:sp>
+        <p:nvSpPr>
+          <p:cNvPr id="27" name="Rounded Rectangle 26"/>
           <p:cNvSpPr/>
           <p:nvPr/>
         </p:nvSpPr>
         <p:spPr>
           <a:xfrm>
-            <a:off x="640080" y="5650992"/>
-            <a:ext cx="822960" cy="713232"/>
+            <a:off x="7726679" y="1234440"/>
+            <a:ext cx="3886200" cy="5074920"/>
           </a:xfrm>
           <a:prstGeom prst="roundRect">
             <a:avLst>
@@ -4055,7 +4317,7 @@
             </a:avLst>
           </a:prstGeom>
           <a:solidFill>
-            <a:srgbClr val="C4B5FD"/>
+            <a:srgbClr val="121C2E"/>
           </a:solidFill>
           <a:ln>
             <a:noFill/>
@@ -4080,19 +4342,20 @@
           <a:lstStyle/>
           <a:p>
             <a:pPr algn="ctr"/>
-          </a:p>
-        </p:txBody>
-      </p:sp>
-      <p:sp>
-        <p:nvSpPr>
-          <p:cNvPr id="25" name="TextBox 24"/>
+            <a:endParaRPr/>
+          </a:p>
+        </p:txBody>
+      </p:sp>
+      <p:sp>
+        <p:nvSpPr>
+          <p:cNvPr id="28" name="TextBox 27"/>
           <p:cNvSpPr txBox="1"/>
           <p:nvPr/>
         </p:nvSpPr>
         <p:spPr>
           <a:xfrm>
-            <a:off x="640080" y="5824728"/>
-            <a:ext cx="822960" cy="365760"/>
+            <a:off x="7909560" y="1332412"/>
+            <a:ext cx="3520440" cy="1088696"/>
           </a:xfrm>
           <a:prstGeom prst="rect">
             <a:avLst/>
@@ -4100,7 +4363,98 @@
           <a:noFill/>
         </p:spPr>
         <p:txBody>
-          <a:bodyPr wrap="square" anchor="t" lIns="0" rIns="0" tIns="0" bIns="0">
+          <a:bodyPr wrap="square" lIns="0" tIns="0" rIns="0" bIns="0" anchor="t">
+            <a:spAutoFit/>
+          </a:bodyPr>
+          <a:lstStyle/>
+          <a:p>
+            <a:pPr algn="ctr">
+              <a:lnSpc>
+                <a:spcPct val="115000"/>
+              </a:lnSpc>
+            </a:pPr>
+            <a:r>
+              <a:rPr lang="zh-CN" altLang="en-US" sz="3200" b="1" dirty="0">
+                <a:solidFill>
+                  <a:srgbClr val="F8FAFC"/>
+                </a:solidFill>
+                <a:latin typeface="Microsoft YaHei"/>
+                <a:ea typeface="Microsoft YaHei"/>
+              </a:rPr>
+              <a:t>发送</a:t>
+            </a:r>
+            <a:r>
+              <a:rPr sz="3200" b="1" dirty="0">
+                <a:solidFill>
+                  <a:srgbClr val="F8FAFC"/>
+                </a:solidFill>
+                <a:latin typeface="Microsoft YaHei"/>
+                <a:ea typeface="Microsoft YaHei"/>
+              </a:rPr>
+              <a:t>“</a:t>
+            </a:r>
+            <a:r>
+              <a:rPr sz="3200" b="1" dirty="0" err="1">
+                <a:solidFill>
+                  <a:srgbClr val="F8FAFC"/>
+                </a:solidFill>
+                <a:latin typeface="Microsoft YaHei"/>
+                <a:ea typeface="Microsoft YaHei"/>
+              </a:rPr>
+              <a:t>我要试一试</a:t>
+            </a:r>
+            <a:r>
+              <a:rPr sz="3200" b="1" dirty="0">
+                <a:solidFill>
+                  <a:srgbClr val="F8FAFC"/>
+                </a:solidFill>
+                <a:latin typeface="Microsoft YaHei"/>
+                <a:ea typeface="Microsoft YaHei"/>
+              </a:rPr>
+              <a:t>
+</a:t>
+            </a:r>
+            <a:r>
+              <a:rPr sz="3200" b="1" dirty="0" err="1">
+                <a:solidFill>
+                  <a:srgbClr val="F8FAFC"/>
+                </a:solidFill>
+                <a:latin typeface="Microsoft YaHei"/>
+                <a:ea typeface="Microsoft YaHei"/>
+              </a:rPr>
+              <a:t>sjtubench</a:t>
+            </a:r>
+            <a:r>
+              <a:rPr sz="3200" b="1" dirty="0">
+                <a:solidFill>
+                  <a:srgbClr val="F8FAFC"/>
+                </a:solidFill>
+                <a:latin typeface="Microsoft YaHei"/>
+                <a:ea typeface="Microsoft YaHei"/>
+              </a:rPr>
+              <a:t>”</a:t>
+            </a:r>
+          </a:p>
+        </p:txBody>
+      </p:sp>
+      <p:sp>
+        <p:nvSpPr>
+          <p:cNvPr id="29" name="TextBox 28"/>
+          <p:cNvSpPr txBox="1"/>
+          <p:nvPr/>
+        </p:nvSpPr>
+        <p:spPr>
+          <a:xfrm>
+            <a:off x="7955279" y="2704012"/>
+            <a:ext cx="3429000" cy="369332"/>
+          </a:xfrm>
+          <a:prstGeom prst="rect">
+            <a:avLst/>
+          </a:prstGeom>
+          <a:noFill/>
+        </p:spPr>
+        <p:txBody>
+          <a:bodyPr wrap="square" lIns="0" tIns="0" rIns="0" bIns="0" anchor="t">
             <a:spAutoFit/>
           </a:bodyPr>
           <a:lstStyle/>
@@ -4111,28 +4465,55 @@
               </a:lnSpc>
             </a:pPr>
             <a:r>
-              <a:rPr sz="1700" b="1">
-                <a:solidFill>
-                  <a:srgbClr val="0B1220"/>
+              <a:rPr sz="2400" b="1" dirty="0" err="1">
+                <a:solidFill>
+                  <a:schemeClr val="bg1"/>
                 </a:solidFill>
                 <a:latin typeface="Microsoft YaHei"/>
                 <a:ea typeface="Microsoft YaHei"/>
               </a:rPr>
-              <a:t>L4</a:t>
-            </a:r>
-          </a:p>
-        </p:txBody>
-      </p:sp>
-      <p:sp>
-        <p:nvSpPr>
-          <p:cNvPr id="26" name="TextBox 25"/>
+              <a:t>登录一下</a:t>
+            </a:r>
+            <a:r>
+              <a:rPr sz="2400" b="1" dirty="0">
+                <a:solidFill>
+                  <a:schemeClr val="bg1"/>
+                </a:solidFill>
+                <a:latin typeface="Microsoft YaHei"/>
+                <a:ea typeface="Microsoft YaHei"/>
+              </a:rPr>
+              <a:t> </a:t>
+            </a:r>
+            <a:r>
+              <a:rPr sz="2400" b="1" dirty="0" err="1">
+                <a:solidFill>
+                  <a:schemeClr val="bg1"/>
+                </a:solidFill>
+                <a:latin typeface="Microsoft YaHei"/>
+                <a:ea typeface="Microsoft YaHei"/>
+              </a:rPr>
+              <a:t>jAccount</a:t>
+            </a:r>
+            <a:endParaRPr sz="2400" b="1" dirty="0">
+              <a:solidFill>
+                <a:schemeClr val="bg1"/>
+              </a:solidFill>
+              <a:latin typeface="Microsoft YaHei"/>
+              <a:ea typeface="Microsoft YaHei"/>
+            </a:endParaRPr>
+          </a:p>
+        </p:txBody>
+      </p:sp>
+      <p:sp>
+        <p:nvSpPr>
+          <p:cNvPr id="30" name="TextBox 29"/>
           <p:cNvSpPr txBox="1"/>
           <p:nvPr/>
         </p:nvSpPr>
         <p:spPr>
           <a:xfrm>
-            <a:off x="1691640" y="5779007"/>
-            <a:ext cx="5394960" cy="457200"/>
+            <a:off x="7955279" y="3142924"/>
+            <a:ext cx="3429000" cy="502920"/>
           </a:xfrm>
           <a:prstGeom prst="rect">
             <a:avLst/>
@@ -4140,47 +4521,132 @@
           <a:noFill/>
         </p:spPr>
         <p:txBody>
-          <a:bodyPr wrap="square" anchor="t" lIns="0" rIns="0" tIns="0" bIns="0">
+          <a:bodyPr wrap="square" lIns="0" tIns="0" rIns="0" bIns="0" anchor="t">
             <a:spAutoFit/>
           </a:bodyPr>
           <a:lstStyle/>
           <a:p>
-            <a:pPr algn="l">
+            <a:pPr algn="ctr">
               <a:lnSpc>
                 <a:spcPct val="100000"/>
               </a:lnSpc>
             </a:pPr>
             <a:r>
-              <a:rPr sz="1600" b="1">
-                <a:solidFill>
-                  <a:srgbClr val="F8FAFC"/>
+              <a:rPr sz="2800" b="1">
+                <a:solidFill>
+                  <a:srgbClr val="22D3EE"/>
                 </a:solidFill>
                 <a:latin typeface="Microsoft YaHei"/>
                 <a:ea typeface="Microsoft YaHei"/>
               </a:rPr>
-              <a:t>每日简报 / 工作流 / 你的 Agent 方案</a:t>
-            </a:r>
-          </a:p>
-        </p:txBody>
-      </p:sp>
-      <p:sp>
-        <p:nvSpPr>
-          <p:cNvPr id="27" name="Rounded Rectangle 26"/>
+              <a:t>↓</a:t>
+            </a:r>
+          </a:p>
+        </p:txBody>
+      </p:sp>
+      <p:sp>
+        <p:nvSpPr>
+          <p:cNvPr id="31" name="TextBox 30"/>
+          <p:cNvSpPr txBox="1"/>
+          <p:nvPr/>
+        </p:nvSpPr>
+        <p:spPr>
+          <a:xfrm>
+            <a:off x="7863840" y="3728140"/>
+            <a:ext cx="3611880" cy="731520"/>
+          </a:xfrm>
+          <a:prstGeom prst="rect">
+            <a:avLst/>
+          </a:prstGeom>
+          <a:noFill/>
+        </p:spPr>
+        <p:txBody>
+          <a:bodyPr wrap="square" lIns="0" tIns="0" rIns="0" bIns="0" anchor="t">
+            <a:spAutoFit/>
+          </a:bodyPr>
+          <a:lstStyle/>
+          <a:p>
+            <a:pPr algn="ctr">
+              <a:lnSpc>
+                <a:spcPct val="100000"/>
+              </a:lnSpc>
+            </a:pPr>
+            <a:r>
+              <a:rPr sz="2000" b="1">
+                <a:solidFill>
+                  <a:srgbClr val="F8FAFC"/>
+                </a:solidFill>
+                <a:latin typeface="Microsoft YaHei"/>
+                <a:ea typeface="Microsoft YaHei"/>
+              </a:rPr>
+              <a:t>AI 能帮我省多少时间？</a:t>
+            </a:r>
+          </a:p>
+        </p:txBody>
+      </p:sp>
+      <p:sp>
+        <p:nvSpPr>
+          <p:cNvPr id="32" name="TextBox 31"/>
+          <p:cNvSpPr txBox="1"/>
+          <p:nvPr/>
+        </p:nvSpPr>
+        <p:spPr>
+          <a:xfrm>
+            <a:off x="7863840" y="5291764"/>
+            <a:ext cx="3611880" cy="307777"/>
+          </a:xfrm>
+          <a:prstGeom prst="rect">
+            <a:avLst/>
+          </a:prstGeom>
+          <a:noFill/>
+        </p:spPr>
+        <p:txBody>
+          <a:bodyPr wrap="square" lIns="0" tIns="0" rIns="0" bIns="0" anchor="t">
+            <a:spAutoFit/>
+          </a:bodyPr>
+          <a:lstStyle/>
+          <a:p>
+            <a:pPr algn="ctr">
+              <a:lnSpc>
+                <a:spcPct val="100000"/>
+              </a:lnSpc>
+            </a:pPr>
+            <a:r>
+              <a:rPr sz="2000" b="1" dirty="0" err="1">
+                <a:solidFill>
+                  <a:srgbClr val="22D3EE"/>
+                </a:solidFill>
+                <a:latin typeface="Microsoft YaHei"/>
+                <a:ea typeface="Microsoft YaHei"/>
+              </a:rPr>
+              <a:t>一切隐私信息严格保存在本地</a:t>
+            </a:r>
+            <a:endParaRPr sz="2000" b="1" dirty="0">
+              <a:solidFill>
+                <a:srgbClr val="22D3EE"/>
+              </a:solidFill>
+              <a:latin typeface="Microsoft YaHei"/>
+              <a:ea typeface="Microsoft YaHei"/>
+            </a:endParaRPr>
+          </a:p>
+        </p:txBody>
+      </p:sp>
+      <p:sp>
+        <p:nvSpPr>
+          <p:cNvPr id="33" name="Rectangle 32"/>
           <p:cNvSpPr/>
           <p:nvPr/>
         </p:nvSpPr>
         <p:spPr>
           <a:xfrm>
-            <a:off x="7726679" y="1234440"/>
-            <a:ext cx="3886200" cy="5074920"/>
-          </a:xfrm>
-          <a:prstGeom prst="roundRect">
-            <a:avLst>
-              <a:gd name="adj" fmla="val 10000"/>
-            </a:avLst>
+            <a:off x="0" y="6400800"/>
+            <a:ext cx="12191695" cy="457200"/>
+          </a:xfrm>
+          <a:prstGeom prst="rect">
+            <a:avLst/>
           </a:prstGeom>
           <a:solidFill>
-            <a:srgbClr val="121C2E"/>
+            <a:srgbClr val="0F1828"/>
           </a:solidFill>
           <a:ln>
             <a:noFill/>
@@ -4205,19 +4671,20 @@
           <a:lstStyle/>
           <a:p>
             <a:pPr algn="ctr"/>
-          </a:p>
-        </p:txBody>
-      </p:sp>
-      <p:sp>
-        <p:nvSpPr>
-          <p:cNvPr id="28" name="TextBox 27"/>
+            <a:endParaRPr/>
+          </a:p>
+        </p:txBody>
+      </p:sp>
+      <p:sp>
+        <p:nvSpPr>
+          <p:cNvPr id="34" name="TextBox 33"/>
           <p:cNvSpPr txBox="1"/>
           <p:nvPr/>
         </p:nvSpPr>
         <p:spPr>
           <a:xfrm>
-            <a:off x="7909560" y="1691640"/>
-            <a:ext cx="3520440" cy="1097280"/>
+            <a:off x="640080" y="6510528"/>
+            <a:ext cx="6858000" cy="274320"/>
           </a:xfrm>
           <a:prstGeom prst="rect">
             <a:avLst/>
@@ -4225,251 +4692,7 @@
           <a:noFill/>
         </p:spPr>
         <p:txBody>
-          <a:bodyPr wrap="square" anchor="t" lIns="0" rIns="0" tIns="0" bIns="0">
-            <a:spAutoFit/>
-          </a:bodyPr>
-          <a:lstStyle/>
-          <a:p>
-            <a:pPr algn="ctr">
-              <a:lnSpc>
-                <a:spcPct val="115000"/>
-              </a:lnSpc>
-            </a:pPr>
-            <a:r>
-              <a:rPr sz="2400" b="1">
-                <a:solidFill>
-                  <a:srgbClr val="F8FAFC"/>
-                </a:solidFill>
-                <a:latin typeface="Microsoft YaHei"/>
-                <a:ea typeface="Microsoft YaHei"/>
-              </a:rPr>
-              <a:t>“我要试一试
-sjtubench”</a:t>
-            </a:r>
-          </a:p>
-        </p:txBody>
-      </p:sp>
-      <p:sp>
-        <p:nvSpPr>
-          <p:cNvPr id="29" name="TextBox 28"/>
-          <p:cNvSpPr txBox="1"/>
-          <p:nvPr/>
-        </p:nvSpPr>
-        <p:spPr>
-          <a:xfrm>
-            <a:off x="7955279" y="3063240"/>
-            <a:ext cx="3429000" cy="365760"/>
-          </a:xfrm>
-          <a:prstGeom prst="rect">
-            <a:avLst/>
-          </a:prstGeom>
-          <a:noFill/>
-        </p:spPr>
-        <p:txBody>
-          <a:bodyPr wrap="square" anchor="t" lIns="0" rIns="0" tIns="0" bIns="0">
-            <a:spAutoFit/>
-          </a:bodyPr>
-          <a:lstStyle/>
-          <a:p>
-            <a:pPr algn="ctr">
-              <a:lnSpc>
-                <a:spcPct val="100000"/>
-              </a:lnSpc>
-            </a:pPr>
-            <a:r>
-              <a:rPr sz="1400" b="0">
-                <a:solidFill>
-                  <a:srgbClr val="94A3B8"/>
-                </a:solidFill>
-                <a:latin typeface="Microsoft YaHei"/>
-                <a:ea typeface="Microsoft YaHei"/>
-              </a:rPr>
-              <a:t>登录一下 jAccount</a:t>
-            </a:r>
-          </a:p>
-        </p:txBody>
-      </p:sp>
-      <p:sp>
-        <p:nvSpPr>
-          <p:cNvPr id="30" name="TextBox 29"/>
-          <p:cNvSpPr txBox="1"/>
-          <p:nvPr/>
-        </p:nvSpPr>
-        <p:spPr>
-          <a:xfrm>
-            <a:off x="7955279" y="3502152"/>
-            <a:ext cx="3429000" cy="502920"/>
-          </a:xfrm>
-          <a:prstGeom prst="rect">
-            <a:avLst/>
-          </a:prstGeom>
-          <a:noFill/>
-        </p:spPr>
-        <p:txBody>
-          <a:bodyPr wrap="square" anchor="t" lIns="0" rIns="0" tIns="0" bIns="0">
-            <a:spAutoFit/>
-          </a:bodyPr>
-          <a:lstStyle/>
-          <a:p>
-            <a:pPr algn="ctr">
-              <a:lnSpc>
-                <a:spcPct val="100000"/>
-              </a:lnSpc>
-            </a:pPr>
-            <a:r>
-              <a:rPr sz="2800" b="1">
-                <a:solidFill>
-                  <a:srgbClr val="22D3EE"/>
-                </a:solidFill>
-                <a:latin typeface="Microsoft YaHei"/>
-                <a:ea typeface="Microsoft YaHei"/>
-              </a:rPr>
-              <a:t>↓</a:t>
-            </a:r>
-          </a:p>
-        </p:txBody>
-      </p:sp>
-      <p:sp>
-        <p:nvSpPr>
-          <p:cNvPr id="31" name="TextBox 30"/>
-          <p:cNvSpPr txBox="1"/>
-          <p:nvPr/>
-        </p:nvSpPr>
-        <p:spPr>
-          <a:xfrm>
-            <a:off x="7863840" y="4087368"/>
-            <a:ext cx="3611880" cy="731520"/>
-          </a:xfrm>
-          <a:prstGeom prst="rect">
-            <a:avLst/>
-          </a:prstGeom>
-          <a:noFill/>
-        </p:spPr>
-        <p:txBody>
-          <a:bodyPr wrap="square" anchor="t" lIns="0" rIns="0" tIns="0" bIns="0">
-            <a:spAutoFit/>
-          </a:bodyPr>
-          <a:lstStyle/>
-          <a:p>
-            <a:pPr algn="ctr">
-              <a:lnSpc>
-                <a:spcPct val="100000"/>
-              </a:lnSpc>
-            </a:pPr>
-            <a:r>
-              <a:rPr sz="2000" b="1">
-                <a:solidFill>
-                  <a:srgbClr val="F8FAFC"/>
-                </a:solidFill>
-                <a:latin typeface="Microsoft YaHei"/>
-                <a:ea typeface="Microsoft YaHei"/>
-              </a:rPr>
-              <a:t>AI 能帮我省多少时间？</a:t>
-            </a:r>
-          </a:p>
-        </p:txBody>
-      </p:sp>
-      <p:sp>
-        <p:nvSpPr>
-          <p:cNvPr id="32" name="TextBox 31"/>
-          <p:cNvSpPr txBox="1"/>
-          <p:nvPr/>
-        </p:nvSpPr>
-        <p:spPr>
-          <a:xfrm>
-            <a:off x="7863840" y="5650992"/>
-            <a:ext cx="3611880" cy="365760"/>
-          </a:xfrm>
-          <a:prstGeom prst="rect">
-            <a:avLst/>
-          </a:prstGeom>
-          <a:noFill/>
-        </p:spPr>
-        <p:txBody>
-          <a:bodyPr wrap="square" anchor="t" lIns="0" rIns="0" tIns="0" bIns="0">
-            <a:spAutoFit/>
-          </a:bodyPr>
-          <a:lstStyle/>
-          <a:p>
-            <a:pPr algn="ctr">
-              <a:lnSpc>
-                <a:spcPct val="100000"/>
-              </a:lnSpc>
-            </a:pPr>
-            <a:r>
-              <a:rPr sz="1100" b="0">
-                <a:solidFill>
-                  <a:srgbClr val="22D3EE"/>
-                </a:solidFill>
-                <a:latin typeface="Microsoft YaHei"/>
-                <a:ea typeface="Microsoft YaHei"/>
-              </a:rPr>
-              <a:t>一切隐私信息严格保存在本地</a:t>
-            </a:r>
-          </a:p>
-        </p:txBody>
-      </p:sp>
-      <p:sp>
-        <p:nvSpPr>
-          <p:cNvPr id="33" name="Rectangle 32"/>
-          <p:cNvSpPr/>
-          <p:nvPr/>
-        </p:nvSpPr>
-        <p:spPr>
-          <a:xfrm>
-            <a:off x="0" y="6400800"/>
-            <a:ext cx="12191695" cy="457200"/>
-          </a:xfrm>
-          <a:prstGeom prst="rect">
-            <a:avLst/>
-          </a:prstGeom>
-          <a:solidFill>
-            <a:srgbClr val="0F1828"/>
-          </a:solidFill>
-          <a:ln>
-            <a:noFill/>
-          </a:ln>
-        </p:spPr>
-        <p:style>
-          <a:lnRef idx="1">
-            <a:schemeClr val="accent1"/>
-          </a:lnRef>
-          <a:fillRef idx="3">
-            <a:schemeClr val="accent1"/>
-          </a:fillRef>
-          <a:effectRef idx="2">
-            <a:schemeClr val="accent1"/>
-          </a:effectRef>
-          <a:fontRef idx="minor">
-            <a:schemeClr val="lt1"/>
-          </a:fontRef>
-        </p:style>
-        <p:txBody>
-          <a:bodyPr rtlCol="0" anchor="ctr"/>
-          <a:lstStyle/>
-          <a:p>
-            <a:pPr algn="ctr"/>
-          </a:p>
-        </p:txBody>
-      </p:sp>
-      <p:sp>
-        <p:nvSpPr>
-          <p:cNvPr id="34" name="TextBox 33"/>
-          <p:cNvSpPr txBox="1"/>
-          <p:nvPr/>
-        </p:nvSpPr>
-        <p:spPr>
-          <a:xfrm>
-            <a:off x="640080" y="6510528"/>
-            <a:ext cx="6858000" cy="274320"/>
-          </a:xfrm>
-          <a:prstGeom prst="rect">
-            <a:avLst/>
-          </a:prstGeom>
-          <a:noFill/>
-        </p:spPr>
-        <p:txBody>
-          <a:bodyPr wrap="square" anchor="t" lIns="0" rIns="0" tIns="0" bIns="0">
+          <a:bodyPr wrap="square" lIns="0" tIns="0" rIns="0" bIns="0" anchor="t">
             <a:spAutoFit/>
           </a:bodyPr>
           <a:lstStyle/>
@@ -4500,7 +4723,7 @@
         </p:nvSpPr>
         <p:spPr>
           <a:xfrm>
-            <a:off x="7863840" y="6528816"/>
+            <a:off x="7863840" y="6169588"/>
             <a:ext cx="3566160" cy="256032"/>
           </a:xfrm>
           <a:prstGeom prst="rect">
@@ -4509,7 +4732,7 @@
           <a:noFill/>
         </p:spPr>
         <p:txBody>
-          <a:bodyPr wrap="square" anchor="t" lIns="0" rIns="0" tIns="0" bIns="0">
+          <a:bodyPr wrap="square" lIns="0" tIns="0" rIns="0" bIns="0" anchor="t">
             <a:spAutoFit/>
           </a:bodyPr>
           <a:lstStyle/>
@@ -4520,14 +4743,44 @@
               </a:lnSpc>
             </a:pPr>
             <a:r>
-              <a:rPr sz="1050" b="0">
+              <a:rPr sz="1050" b="0" dirty="0" err="1">
                 <a:solidFill>
                   <a:srgbClr val="94A3B8"/>
                 </a:solidFill>
                 <a:latin typeface="Microsoft YaHei"/>
                 <a:ea typeface="Microsoft YaHei"/>
               </a:rPr>
-              <a:t>娱乐向 · 非官方 · MIT</a:t>
+              <a:t>娱乐向</a:t>
+            </a:r>
+            <a:r>
+              <a:rPr sz="1050" b="0" dirty="0">
+                <a:solidFill>
+                  <a:srgbClr val="94A3B8"/>
+                </a:solidFill>
+                <a:latin typeface="Microsoft YaHei"/>
+                <a:ea typeface="Microsoft YaHei"/>
+              </a:rPr>
+              <a:t> · </a:t>
+            </a:r>
+            <a:r>
+              <a:rPr sz="1050" b="0" dirty="0" err="1">
+                <a:solidFill>
+                  <a:srgbClr val="94A3B8"/>
+                </a:solidFill>
+                <a:latin typeface="Microsoft YaHei"/>
+                <a:ea typeface="Microsoft YaHei"/>
+              </a:rPr>
+              <a:t>非官方</a:t>
+            </a:r>
+            <a:r>
+              <a:rPr sz="1050" b="0" dirty="0">
+                <a:solidFill>
+                  <a:srgbClr val="94A3B8"/>
+                </a:solidFill>
+                <a:latin typeface="Microsoft YaHei"/>
+                <a:ea typeface="Microsoft YaHei"/>
+              </a:rPr>
+              <a:t> · MIT</a:t>
             </a:r>
           </a:p>
         </p:txBody>

</xml_diff>